<commit_message>
Präsentationsmaster auf Maiershirts-Brand umstellen
- Logo als Vektor nachgebaut (Bergmarke + Wortmarke), schwarz/weiß als PNG
- Farben nach Brand Colors Mai 2026: Schwarz, Asparagus, Warm Sand, Weiß
- Schrift Inter, Kennzahlen-Karten und Abschlussfolie angepasst

Co-Authored-By: Claude Fable 5.1 <noreply@anthropic.com>
Claude-Session: https://claude.ai/code/session_01Ga6KtWh2QFwjDz49gmiv89
</commit_message>
<xml_diff>
--- a/presentation/dist/Maiershirts_Master.pptx
+++ b/presentation/dist/Maiershirts_Master.pptx
@@ -144,7 +144,7 @@
           </c:tx>
           <c:spPr>
             <a:solidFill>
-              <a:srgbClr val="22C55E"/>
+              <a:srgbClr val="819E72"/>
             </a:solidFill>
             <a:effectLst/>
           </c:spPr>
@@ -158,9 +158,9 @@
                 <a:pPr>
                   <a:defRPr b="0" i="0" strike="noStrike" sz="1100" u="none">
                     <a:solidFill>
-                      <a:srgbClr val="111827"/>
+                      <a:srgbClr val="0F0F0F"/>
                     </a:solidFill>
-                    <a:latin typeface="Calibri"/>
+                    <a:latin typeface="Inter"/>
                   </a:defRPr>
                 </a:pPr>
               </a:p>
@@ -232,9 +232,9 @@
               <a:pPr>
                 <a:defRPr b="0" i="0" strike="noStrike" sz="1100" u="none">
                   <a:solidFill>
-                    <a:srgbClr val="111827"/>
+                    <a:srgbClr val="0F0F0F"/>
                   </a:solidFill>
-                  <a:latin typeface="Calibri"/>
+                  <a:latin typeface="Inter"/>
                 </a:defRPr>
               </a:pPr>
             </a:p>
@@ -278,9 +278,9 @@
             <a:pPr>
               <a:defRPr sz="1100" b="0" i="0" u="none" strike="noStrike">
                 <a:solidFill>
-                  <a:srgbClr val="6B7280"/>
-                </a:solidFill>
-                <a:latin typeface="Calibri"/>
+                  <a:srgbClr val="5C5C58"/>
+                </a:solidFill>
+                <a:latin typeface="Inter"/>
               </a:defRPr>
             </a:pPr>
             <a:endParaRPr lang="en-US"/>
@@ -303,7 +303,7 @@
           <c:spPr>
             <a:ln w="6350" cap="flat">
               <a:solidFill>
-                <a:srgbClr val="E5E7EB"/>
+                <a:srgbClr val="D9D2C5"/>
               </a:solidFill>
               <a:prstDash val="solid"/>
               <a:round/>
@@ -328,9 +328,9 @@
             <a:pPr>
               <a:defRPr sz="1000" b="0" i="0" u="none" strike="noStrike">
                 <a:solidFill>
-                  <a:srgbClr val="6B7280"/>
-                </a:solidFill>
-                <a:latin typeface="Calibri"/>
+                  <a:srgbClr val="5C5C58"/>
+                </a:solidFill>
+                <a:latin typeface="Inter"/>
               </a:defRPr>
             </a:pPr>
             <a:endParaRPr lang="en-US"/>
@@ -1669,8 +1669,8 @@
         </p:blipFill>
         <p:spPr>
           <a:xfrm>
-            <a:off x="548640" y="502920"/>
-            <a:ext cx="3291840" cy="594360"/>
+            <a:off x="548640" y="457200"/>
+            <a:ext cx="2011680" cy="1097280"/>
           </a:xfrm>
           <a:prstGeom prst="rect">
             <a:avLst/>
@@ -1705,9 +1705,9 @@
                 <a:solidFill>
                   <a:srgbClr val="FFFFFF"/>
                 </a:solidFill>
-                <a:latin typeface="Calibri" pitchFamily="34" charset="0"/>
-                <a:ea typeface="Calibri" pitchFamily="34" charset="-122"/>
-                <a:cs typeface="Calibri" pitchFamily="34" charset="-120"/>
+                <a:latin typeface="Inter" pitchFamily="34" charset="0"/>
+                <a:ea typeface="Inter" pitchFamily="34" charset="-122"/>
+                <a:cs typeface="Inter" pitchFamily="34" charset="-120"/>
               </a:defRPr>
             </a:lvl1pPr>
           </a:lstStyle>
@@ -1720,9 +1720,9 @@
                 <a:solidFill>
                   <a:srgbClr val="FFFFFF"/>
                 </a:solidFill>
-                <a:latin typeface="Calibri" pitchFamily="34" charset="0"/>
-                <a:ea typeface="Calibri" pitchFamily="34" charset="-122"/>
-                <a:cs typeface="Calibri" pitchFamily="34" charset="-120"/>
+                <a:latin typeface="Inter" pitchFamily="34" charset="0"/>
+                <a:ea typeface="Inter" pitchFamily="34" charset="-122"/>
+                <a:cs typeface="Inter" pitchFamily="34" charset="-120"/>
               </a:rPr>
               <a:t>Titel der Präsentation</a:t>
             </a:r>
@@ -1756,11 +1756,11 @@
               <a:buNone/>
               <a:defRPr lang="en-US" sz="1800" dirty="0">
                 <a:solidFill>
-                  <a:srgbClr val="9AA4B2"/>
-                </a:solidFill>
-                <a:latin typeface="Calibri" pitchFamily="34" charset="0"/>
-                <a:ea typeface="Calibri" pitchFamily="34" charset="-122"/>
-                <a:cs typeface="Calibri" pitchFamily="34" charset="-120"/>
+                  <a:srgbClr val="CFC8BB"/>
+                </a:solidFill>
+                <a:latin typeface="Inter" pitchFamily="34" charset="0"/>
+                <a:ea typeface="Inter" pitchFamily="34" charset="-122"/>
+                <a:cs typeface="Inter" pitchFamily="34" charset="-120"/>
               </a:defRPr>
             </a:lvl1pPr>
           </a:lstStyle>
@@ -1771,11 +1771,11 @@
             <a:r>
               <a:rPr lang="en-US" sz="1800" dirty="0">
                 <a:solidFill>
-                  <a:srgbClr val="9AA4B2"/>
-                </a:solidFill>
-                <a:latin typeface="Calibri" pitchFamily="34" charset="0"/>
-                <a:ea typeface="Calibri" pitchFamily="34" charset="-122"/>
-                <a:cs typeface="Calibri" pitchFamily="34" charset="-120"/>
+                  <a:srgbClr val="CFC8BB"/>
+                </a:solidFill>
+                <a:latin typeface="Inter" pitchFamily="34" charset="0"/>
+                <a:ea typeface="Inter" pitchFamily="34" charset="-122"/>
+                <a:cs typeface="Inter" pitchFamily="34" charset="-120"/>
               </a:rPr>
               <a:t>Untertitel · Datum</a:t>
             </a:r>
@@ -1810,11 +1810,11 @@
             <a:r>
               <a:rPr lang="en-US" sz="1000" dirty="0">
                 <a:solidFill>
-                  <a:srgbClr val="9AA4B2"/>
-                </a:solidFill>
-                <a:latin typeface="Calibri" pitchFamily="34" charset="0"/>
-                <a:ea typeface="Calibri" pitchFamily="34" charset="-122"/>
-                <a:cs typeface="Calibri" pitchFamily="34" charset="-120"/>
+                  <a:srgbClr val="CFC8BB"/>
+                </a:solidFill>
+                <a:latin typeface="Inter" pitchFamily="34" charset="0"/>
+                <a:ea typeface="Inter" pitchFamily="34" charset="-122"/>
+                <a:cs typeface="Inter" pitchFamily="34" charset="-120"/>
               </a:rPr>
               <a:t>Maiershirts</a:t>
             </a:r>
@@ -1877,7 +1877,7 @@
         <p:spPr>
           <a:xfrm>
             <a:off x="548640" y="411480"/>
-            <a:ext cx="2194560" cy="411480"/>
+            <a:ext cx="1325880" cy="731520"/>
           </a:xfrm>
           <a:prstGeom prst="rect">
             <a:avLst/>
@@ -1910,11 +1910,11 @@
               <a:buNone/>
               <a:defRPr lang="en-US" sz="5400" b="1" dirty="0">
                 <a:solidFill>
-                  <a:srgbClr val="22C55E"/>
-                </a:solidFill>
-                <a:latin typeface="Calibri" pitchFamily="34" charset="0"/>
-                <a:ea typeface="Calibri" pitchFamily="34" charset="-122"/>
-                <a:cs typeface="Calibri" pitchFamily="34" charset="-120"/>
+                  <a:srgbClr val="819E72"/>
+                </a:solidFill>
+                <a:latin typeface="Inter" pitchFamily="34" charset="0"/>
+                <a:ea typeface="Inter" pitchFamily="34" charset="-122"/>
+                <a:cs typeface="Inter" pitchFamily="34" charset="-120"/>
               </a:defRPr>
             </a:lvl1pPr>
           </a:lstStyle>
@@ -1925,11 +1925,11 @@
             <a:r>
               <a:rPr lang="en-US" sz="5400" b="1" dirty="0">
                 <a:solidFill>
-                  <a:srgbClr val="22C55E"/>
-                </a:solidFill>
-                <a:latin typeface="Calibri" pitchFamily="34" charset="0"/>
-                <a:ea typeface="Calibri" pitchFamily="34" charset="-122"/>
-                <a:cs typeface="Calibri" pitchFamily="34" charset="-120"/>
+                  <a:srgbClr val="819E72"/>
+                </a:solidFill>
+                <a:latin typeface="Inter" pitchFamily="34" charset="0"/>
+                <a:ea typeface="Inter" pitchFamily="34" charset="-122"/>
+                <a:cs typeface="Inter" pitchFamily="34" charset="-120"/>
               </a:rPr>
               <a:t>01</a:t>
             </a:r>
@@ -1965,9 +1965,9 @@
                 <a:solidFill>
                   <a:srgbClr val="FFFFFF"/>
                 </a:solidFill>
-                <a:latin typeface="Calibri" pitchFamily="34" charset="0"/>
-                <a:ea typeface="Calibri" pitchFamily="34" charset="-122"/>
-                <a:cs typeface="Calibri" pitchFamily="34" charset="-120"/>
+                <a:latin typeface="Inter" pitchFamily="34" charset="0"/>
+                <a:ea typeface="Inter" pitchFamily="34" charset="-122"/>
+                <a:cs typeface="Inter" pitchFamily="34" charset="-120"/>
               </a:defRPr>
             </a:lvl1pPr>
           </a:lstStyle>
@@ -1980,9 +1980,9 @@
                 <a:solidFill>
                   <a:srgbClr val="FFFFFF"/>
                 </a:solidFill>
-                <a:latin typeface="Calibri" pitchFamily="34" charset="0"/>
-                <a:ea typeface="Calibri" pitchFamily="34" charset="-122"/>
-                <a:cs typeface="Calibri" pitchFamily="34" charset="-120"/>
+                <a:latin typeface="Inter" pitchFamily="34" charset="0"/>
+                <a:ea typeface="Inter" pitchFamily="34" charset="-122"/>
+                <a:cs typeface="Inter" pitchFamily="34" charset="-120"/>
               </a:rPr>
               <a:t>Abschnittstitel</a:t>
             </a:r>
@@ -2016,11 +2016,11 @@
               <a:buNone/>
               <a:defRPr lang="en-US" sz="1600" dirty="0">
                 <a:solidFill>
-                  <a:srgbClr val="9AA4B2"/>
-                </a:solidFill>
-                <a:latin typeface="Calibri" pitchFamily="34" charset="0"/>
-                <a:ea typeface="Calibri" pitchFamily="34" charset="-122"/>
-                <a:cs typeface="Calibri" pitchFamily="34" charset="-120"/>
+                  <a:srgbClr val="CFC8BB"/>
+                </a:solidFill>
+                <a:latin typeface="Inter" pitchFamily="34" charset="0"/>
+                <a:ea typeface="Inter" pitchFamily="34" charset="-122"/>
+                <a:cs typeface="Inter" pitchFamily="34" charset="-120"/>
               </a:defRPr>
             </a:lvl1pPr>
           </a:lstStyle>
@@ -2031,11 +2031,11 @@
             <a:r>
               <a:rPr lang="en-US" sz="1600" dirty="0">
                 <a:solidFill>
-                  <a:srgbClr val="9AA4B2"/>
-                </a:solidFill>
-                <a:latin typeface="Calibri" pitchFamily="34" charset="0"/>
-                <a:ea typeface="Calibri" pitchFamily="34" charset="-122"/>
-                <a:cs typeface="Calibri" pitchFamily="34" charset="-120"/>
+                  <a:srgbClr val="CFC8BB"/>
+                </a:solidFill>
+                <a:latin typeface="Inter" pitchFamily="34" charset="0"/>
+                <a:ea typeface="Inter" pitchFamily="34" charset="-122"/>
+                <a:cs typeface="Inter" pitchFamily="34" charset="-120"/>
               </a:rPr>
               <a:t>Kurzbeschreibung des Abschnitts</a:t>
             </a:r>
@@ -2090,8 +2090,8 @@
         </p:blipFill>
         <p:spPr>
           <a:xfrm>
-            <a:off x="6903720" y="347472"/>
-            <a:ext cx="1783080" cy="384048"/>
+            <a:off x="7543800" y="274320"/>
+            <a:ext cx="1143000" cy="621792"/>
           </a:xfrm>
           <a:prstGeom prst="rect">
             <a:avLst/>
@@ -2109,7 +2109,7 @@
         <p:spPr>
           <a:xfrm>
             <a:off x="457200" y="320040"/>
-            <a:ext cx="6217920" cy="685800"/>
+            <a:ext cx="6858000" cy="685800"/>
           </a:xfrm>
           <a:prstGeom prst="rect">
             <a:avLst/>
@@ -2124,11 +2124,11 @@
               <a:buNone/>
               <a:defRPr lang="en-US" sz="2800" b="1" dirty="0">
                 <a:solidFill>
-                  <a:srgbClr val="111827"/>
-                </a:solidFill>
-                <a:latin typeface="Calibri" pitchFamily="34" charset="0"/>
-                <a:ea typeface="Calibri" pitchFamily="34" charset="-122"/>
-                <a:cs typeface="Calibri" pitchFamily="34" charset="-120"/>
+                  <a:srgbClr val="0F0F0F"/>
+                </a:solidFill>
+                <a:latin typeface="Inter" pitchFamily="34" charset="0"/>
+                <a:ea typeface="Inter" pitchFamily="34" charset="-122"/>
+                <a:cs typeface="Inter" pitchFamily="34" charset="-120"/>
               </a:defRPr>
             </a:lvl1pPr>
           </a:lstStyle>
@@ -2139,11 +2139,11 @@
             <a:r>
               <a:rPr lang="en-US" sz="2800" b="1" dirty="0">
                 <a:solidFill>
-                  <a:srgbClr val="111827"/>
-                </a:solidFill>
-                <a:latin typeface="Calibri" pitchFamily="34" charset="0"/>
-                <a:ea typeface="Calibri" pitchFamily="34" charset="-122"/>
-                <a:cs typeface="Calibri" pitchFamily="34" charset="-120"/>
+                  <a:srgbClr val="0F0F0F"/>
+                </a:solidFill>
+                <a:latin typeface="Inter" pitchFamily="34" charset="0"/>
+                <a:ea typeface="Inter" pitchFamily="34" charset="-122"/>
+                <a:cs typeface="Inter" pitchFamily="34" charset="-120"/>
               </a:rPr>
               <a:t>Folientitel</a:t>
             </a:r>
@@ -2178,11 +2178,11 @@
             <a:r>
               <a:rPr lang="en-US" sz="900" dirty="0">
                 <a:solidFill>
-                  <a:srgbClr val="6B7280"/>
-                </a:solidFill>
-                <a:latin typeface="Calibri" pitchFamily="34" charset="0"/>
-                <a:ea typeface="Calibri" pitchFamily="34" charset="-122"/>
-                <a:cs typeface="Calibri" pitchFamily="34" charset="-120"/>
+                  <a:srgbClr val="5C5C58"/>
+                </a:solidFill>
+                <a:latin typeface="Inter" pitchFamily="34" charset="0"/>
+                <a:ea typeface="Inter" pitchFamily="34" charset="-122"/>
+                <a:cs typeface="Inter" pitchFamily="34" charset="-120"/>
               </a:rPr>
               <a:t>Maiershirts</a:t>
             </a:r>
@@ -2220,11 +2220,11 @@
             <a:lvl1pPr>
               <a:defRPr sz="900">
                 <a:solidFill>
-                  <a:srgbClr val="6B7280"/>
-                </a:solidFill>
-                <a:latin typeface="Calibri"/>
-                <a:ea typeface="Calibri"/>
-                <a:cs typeface="Calibri"/>
+                  <a:srgbClr val="5C5C58"/>
+                </a:solidFill>
+                <a:latin typeface="Inter"/>
+                <a:ea typeface="Inter"/>
+                <a:cs typeface="Inter"/>
               </a:defRPr>
             </a:lvl1pPr>
           </a:lstStyle>
@@ -2292,8 +2292,8 @@
         </p:blipFill>
         <p:spPr>
           <a:xfrm>
-            <a:off x="2743200" y="1051560"/>
-            <a:ext cx="3657600" cy="685800"/>
+            <a:off x="3383280" y="640080"/>
+            <a:ext cx="2377440" cy="1298448"/>
           </a:xfrm>
           <a:prstGeom prst="rect">
             <a:avLst/>
@@ -2328,9 +2328,9 @@
                 <a:solidFill>
                   <a:srgbClr val="FFFFFF"/>
                 </a:solidFill>
-                <a:latin typeface="Calibri" pitchFamily="34" charset="0"/>
-                <a:ea typeface="Calibri" pitchFamily="34" charset="-122"/>
-                <a:cs typeface="Calibri" pitchFamily="34" charset="-120"/>
+                <a:latin typeface="Inter" pitchFamily="34" charset="0"/>
+                <a:ea typeface="Inter" pitchFamily="34" charset="-122"/>
+                <a:cs typeface="Inter" pitchFamily="34" charset="-120"/>
               </a:defRPr>
             </a:lvl1pPr>
           </a:lstStyle>
@@ -2343,9 +2343,9 @@
                 <a:solidFill>
                   <a:srgbClr val="FFFFFF"/>
                 </a:solidFill>
-                <a:latin typeface="Calibri" pitchFamily="34" charset="0"/>
-                <a:ea typeface="Calibri" pitchFamily="34" charset="-122"/>
-                <a:cs typeface="Calibri" pitchFamily="34" charset="-120"/>
+                <a:latin typeface="Inter" pitchFamily="34" charset="0"/>
+                <a:ea typeface="Inter" pitchFamily="34" charset="-122"/>
+                <a:cs typeface="Inter" pitchFamily="34" charset="-120"/>
               </a:rPr>
               <a:t>Vielen Dank</a:t>
             </a:r>
@@ -2379,11 +2379,11 @@
               <a:buNone/>
               <a:defRPr lang="en-US" sz="1400" dirty="0">
                 <a:solidFill>
-                  <a:srgbClr val="9AA4B2"/>
-                </a:solidFill>
-                <a:latin typeface="Calibri" pitchFamily="34" charset="0"/>
-                <a:ea typeface="Calibri" pitchFamily="34" charset="-122"/>
-                <a:cs typeface="Calibri" pitchFamily="34" charset="-120"/>
+                  <a:srgbClr val="CFC8BB"/>
+                </a:solidFill>
+                <a:latin typeface="Inter" pitchFamily="34" charset="0"/>
+                <a:ea typeface="Inter" pitchFamily="34" charset="-122"/>
+                <a:cs typeface="Inter" pitchFamily="34" charset="-120"/>
               </a:defRPr>
             </a:lvl1pPr>
           </a:lstStyle>
@@ -2394,11 +2394,11 @@
             <a:r>
               <a:rPr lang="en-US" sz="1400" dirty="0">
                 <a:solidFill>
-                  <a:srgbClr val="9AA4B2"/>
-                </a:solidFill>
-                <a:latin typeface="Calibri" pitchFamily="34" charset="0"/>
-                <a:ea typeface="Calibri" pitchFamily="34" charset="-122"/>
-                <a:cs typeface="Calibri" pitchFamily="34" charset="-120"/>
+                  <a:srgbClr val="CFC8BB"/>
+                </a:solidFill>
+                <a:latin typeface="Inter" pitchFamily="34" charset="0"/>
+                <a:ea typeface="Inter" pitchFamily="34" charset="-122"/>
+                <a:cs typeface="Inter" pitchFamily="34" charset="-120"/>
               </a:rPr>
               <a:t>Kontakt</a:t>
             </a:r>
@@ -2461,11 +2461,11 @@
             <a:lvl1pPr>
               <a:defRPr sz="900">
                 <a:solidFill>
-                  <a:srgbClr val="6B7280"/>
-                </a:solidFill>
-                <a:latin typeface="Calibri"/>
-                <a:ea typeface="Calibri"/>
-                <a:cs typeface="Calibri"/>
+                  <a:srgbClr val="5C5C58"/>
+                </a:solidFill>
+                <a:latin typeface="Inter"/>
+                <a:ea typeface="Inter"/>
+                <a:cs typeface="Inter"/>
               </a:defRPr>
             </a:lvl1pPr>
           </a:lstStyle>
@@ -2791,9 +2791,9 @@
                 <a:solidFill>
                   <a:srgbClr val="FFFFFF"/>
                 </a:solidFill>
-                <a:latin typeface="Calibri" pitchFamily="34" charset="0"/>
-                <a:ea typeface="Calibri" pitchFamily="34" charset="-122"/>
-                <a:cs typeface="Calibri" pitchFamily="34" charset="-120"/>
+                <a:latin typeface="Inter" pitchFamily="34" charset="0"/>
+                <a:ea typeface="Inter" pitchFamily="34" charset="-122"/>
+                <a:cs typeface="Inter" pitchFamily="34" charset="-120"/>
               </a:rPr>
               <a:t>Angebotspräsentation</a:t>
             </a:r>
@@ -2830,11 +2830,11 @@
             <a:r>
               <a:rPr lang="en-US" sz="1800" dirty="0">
                 <a:solidFill>
-                  <a:srgbClr val="9AA4B2"/>
-                </a:solidFill>
-                <a:latin typeface="Calibri" pitchFamily="34" charset="0"/>
-                <a:ea typeface="Calibri" pitchFamily="34" charset="-122"/>
-                <a:cs typeface="Calibri" pitchFamily="34" charset="-120"/>
+                  <a:srgbClr val="CFC8BB"/>
+                </a:solidFill>
+                <a:latin typeface="Inter" pitchFamily="34" charset="0"/>
+                <a:ea typeface="Inter" pitchFamily="34" charset="-122"/>
+                <a:cs typeface="Inter" pitchFamily="34" charset="-120"/>
               </a:rPr>
               <a:t>Individuell bedruckte Textilien für Teams, Vereine und Unternehmen · September 2026</a:t>
             </a:r>
@@ -2898,9 +2898,9 @@
                 <a:solidFill>
                   <a:srgbClr val="FFFFFF"/>
                 </a:solidFill>
-                <a:latin typeface="Calibri" pitchFamily="34" charset="0"/>
-                <a:ea typeface="Calibri" pitchFamily="34" charset="-122"/>
-                <a:cs typeface="Calibri" pitchFamily="34" charset="-120"/>
+                <a:latin typeface="Inter" pitchFamily="34" charset="0"/>
+                <a:ea typeface="Inter" pitchFamily="34" charset="-122"/>
+                <a:cs typeface="Inter" pitchFamily="34" charset="-120"/>
               </a:rPr>
               <a:t>Vielen Dank für Ihr Interesse</a:t>
             </a:r>
@@ -2937,11 +2937,11 @@
             <a:r>
               <a:rPr lang="en-US" sz="1400" dirty="0">
                 <a:solidFill>
-                  <a:srgbClr val="9AA4B2"/>
-                </a:solidFill>
-                <a:latin typeface="Calibri" pitchFamily="34" charset="0"/>
-                <a:ea typeface="Calibri" pitchFamily="34" charset="-122"/>
-                <a:cs typeface="Calibri" pitchFamily="34" charset="-120"/>
+                  <a:srgbClr val="CFC8BB"/>
+                </a:solidFill>
+                <a:latin typeface="Inter" pitchFamily="34" charset="0"/>
+                <a:ea typeface="Inter" pitchFamily="34" charset="-122"/>
+                <a:cs typeface="Inter" pitchFamily="34" charset="-120"/>
               </a:rPr>
               <a:t>Wir freuen uns auf Ihre Anfrage.</a:t>
             </a:r>
@@ -2964,11 +2964,11 @@
             <a:avLst/>
           </a:prstGeom>
           <a:solidFill>
-            <a:srgbClr val="22C55E"/>
+            <a:srgbClr val="819E72"/>
           </a:solidFill>
           <a:ln w="12700">
             <a:solidFill>
-              <a:srgbClr val="22C55E"/>
+              <a:srgbClr val="819E72"/>
             </a:solidFill>
             <a:prstDash val="solid"/>
           </a:ln>
@@ -3025,11 +3025,11 @@
             <a:r>
               <a:rPr lang="en-US" sz="1200" dirty="0">
                 <a:solidFill>
-                  <a:srgbClr val="E5E7EB"/>
-                </a:solidFill>
-                <a:latin typeface="Calibri" pitchFamily="34" charset="0"/>
-                <a:ea typeface="Calibri" pitchFamily="34" charset="-122"/>
-                <a:cs typeface="Calibri" pitchFamily="34" charset="-120"/>
+                  <a:srgbClr val="FFFFFF"/>
+                </a:solidFill>
+                <a:latin typeface="Inter" pitchFamily="34" charset="0"/>
+                <a:ea typeface="Inter" pitchFamily="34" charset="-122"/>
+                <a:cs typeface="Inter" pitchFamily="34" charset="-120"/>
               </a:rPr>
               <a:t>info@maiershirts.de</a:t>
             </a:r>
@@ -3052,11 +3052,11 @@
             <a:avLst/>
           </a:prstGeom>
           <a:solidFill>
-            <a:srgbClr val="22C55E"/>
+            <a:srgbClr val="819E72"/>
           </a:solidFill>
           <a:ln w="12700">
             <a:solidFill>
-              <a:srgbClr val="22C55E"/>
+              <a:srgbClr val="819E72"/>
             </a:solidFill>
             <a:prstDash val="solid"/>
           </a:ln>
@@ -3113,11 +3113,11 @@
             <a:r>
               <a:rPr lang="en-US" sz="1200" dirty="0">
                 <a:solidFill>
-                  <a:srgbClr val="E5E7EB"/>
-                </a:solidFill>
-                <a:latin typeface="Calibri" pitchFamily="34" charset="0"/>
-                <a:ea typeface="Calibri" pitchFamily="34" charset="-122"/>
-                <a:cs typeface="Calibri" pitchFamily="34" charset="-120"/>
+                  <a:srgbClr val="FFFFFF"/>
+                </a:solidFill>
+                <a:latin typeface="Inter" pitchFamily="34" charset="0"/>
+                <a:ea typeface="Inter" pitchFamily="34" charset="-122"/>
+                <a:cs typeface="Inter" pitchFamily="34" charset="-120"/>
               </a:rPr>
               <a:t>+49 (0) 000 000000</a:t>
             </a:r>
@@ -3140,11 +3140,11 @@
             <a:avLst/>
           </a:prstGeom>
           <a:solidFill>
-            <a:srgbClr val="22C55E"/>
+            <a:srgbClr val="819E72"/>
           </a:solidFill>
           <a:ln w="12700">
             <a:solidFill>
-              <a:srgbClr val="22C55E"/>
+              <a:srgbClr val="819E72"/>
             </a:solidFill>
             <a:prstDash val="solid"/>
           </a:ln>
@@ -3201,11 +3201,11 @@
             <a:r>
               <a:rPr lang="en-US" sz="1200" dirty="0">
                 <a:solidFill>
-                  <a:srgbClr val="E5E7EB"/>
-                </a:solidFill>
-                <a:latin typeface="Calibri" pitchFamily="34" charset="0"/>
-                <a:ea typeface="Calibri" pitchFamily="34" charset="-122"/>
-                <a:cs typeface="Calibri" pitchFamily="34" charset="-120"/>
+                  <a:srgbClr val="FFFFFF"/>
+                </a:solidFill>
+                <a:latin typeface="Inter" pitchFamily="34" charset="0"/>
+                <a:ea typeface="Inter" pitchFamily="34" charset="-122"/>
+                <a:cs typeface="Inter" pitchFamily="34" charset="-120"/>
               </a:rPr>
               <a:t>www.maiershirts.de</a:t>
             </a:r>
@@ -3249,7 +3249,7 @@
         <p:spPr>
           <a:xfrm>
             <a:off x="457200" y="320040"/>
-            <a:ext cx="6217920" cy="685800"/>
+            <a:ext cx="6858000" cy="685800"/>
           </a:xfrm>
           <a:prstGeom prst="rect">
             <a:avLst/>
@@ -3267,11 +3267,11 @@
             <a:r>
               <a:rPr lang="en-US" sz="2800" b="1" dirty="0">
                 <a:solidFill>
-                  <a:srgbClr val="111827"/>
-                </a:solidFill>
-                <a:latin typeface="Calibri" pitchFamily="34" charset="0"/>
-                <a:ea typeface="Calibri" pitchFamily="34" charset="-122"/>
-                <a:cs typeface="Calibri" pitchFamily="34" charset="-120"/>
+                  <a:srgbClr val="0F0F0F"/>
+                </a:solidFill>
+                <a:latin typeface="Inter" pitchFamily="34" charset="0"/>
+                <a:ea typeface="Inter" pitchFamily="34" charset="-122"/>
+                <a:cs typeface="Inter" pitchFamily="34" charset="-120"/>
               </a:rPr>
               <a:t>Agenda</a:t>
             </a:r>
@@ -3294,11 +3294,11 @@
             <a:avLst/>
           </a:prstGeom>
           <a:solidFill>
-            <a:srgbClr val="E9F9EF"/>
+            <a:srgbClr val="E3ECDD"/>
           </a:solidFill>
           <a:ln w="12700">
             <a:solidFill>
-              <a:srgbClr val="E9F9EF"/>
+              <a:srgbClr val="E3ECDD"/>
             </a:solidFill>
             <a:prstDash val="solid"/>
           </a:ln>
@@ -3355,11 +3355,11 @@
             <a:r>
               <a:rPr lang="en-US" sz="2000" b="1" dirty="0">
                 <a:solidFill>
-                  <a:srgbClr val="15803D"/>
-                </a:solidFill>
-                <a:latin typeface="Calibri" pitchFamily="34" charset="0"/>
-                <a:ea typeface="Calibri" pitchFamily="34" charset="-122"/>
-                <a:cs typeface="Calibri" pitchFamily="34" charset="-120"/>
+                  <a:srgbClr val="677E5B"/>
+                </a:solidFill>
+                <a:latin typeface="Inter" pitchFamily="34" charset="0"/>
+                <a:ea typeface="Inter" pitchFamily="34" charset="-122"/>
+                <a:cs typeface="Inter" pitchFamily="34" charset="-120"/>
               </a:rPr>
               <a:t>01</a:t>
             </a:r>
@@ -3394,11 +3394,11 @@
             <a:r>
               <a:rPr lang="en-US" sz="1800" b="1" dirty="0">
                 <a:solidFill>
-                  <a:srgbClr val="111827"/>
-                </a:solidFill>
-                <a:latin typeface="Calibri" pitchFamily="34" charset="0"/>
-                <a:ea typeface="Calibri" pitchFamily="34" charset="-122"/>
-                <a:cs typeface="Calibri" pitchFamily="34" charset="-120"/>
+                  <a:srgbClr val="0F0F0F"/>
+                </a:solidFill>
+                <a:latin typeface="Inter" pitchFamily="34" charset="0"/>
+                <a:ea typeface="Inter" pitchFamily="34" charset="-122"/>
+                <a:cs typeface="Inter" pitchFamily="34" charset="-120"/>
               </a:rPr>
               <a:t>Über uns</a:t>
             </a:r>
@@ -3433,11 +3433,11 @@
             <a:r>
               <a:rPr lang="en-US" sz="1200" dirty="0">
                 <a:solidFill>
-                  <a:srgbClr val="6B7280"/>
-                </a:solidFill>
-                <a:latin typeface="Calibri" pitchFamily="34" charset="0"/>
-                <a:ea typeface="Calibri" pitchFamily="34" charset="-122"/>
-                <a:cs typeface="Calibri" pitchFamily="34" charset="-120"/>
+                  <a:srgbClr val="5C5C58"/>
+                </a:solidFill>
+                <a:latin typeface="Inter" pitchFamily="34" charset="0"/>
+                <a:ea typeface="Inter" pitchFamily="34" charset="-122"/>
+                <a:cs typeface="Inter" pitchFamily="34" charset="-120"/>
               </a:rPr>
               <a:t>Wer wir sind und wofür wir stehen</a:t>
             </a:r>
@@ -3460,11 +3460,11 @@
             <a:avLst/>
           </a:prstGeom>
           <a:solidFill>
-            <a:srgbClr val="E9F9EF"/>
+            <a:srgbClr val="E3ECDD"/>
           </a:solidFill>
           <a:ln w="12700">
             <a:solidFill>
-              <a:srgbClr val="E9F9EF"/>
+              <a:srgbClr val="E3ECDD"/>
             </a:solidFill>
             <a:prstDash val="solid"/>
           </a:ln>
@@ -3521,11 +3521,11 @@
             <a:r>
               <a:rPr lang="en-US" sz="2000" b="1" dirty="0">
                 <a:solidFill>
-                  <a:srgbClr val="15803D"/>
-                </a:solidFill>
-                <a:latin typeface="Calibri" pitchFamily="34" charset="0"/>
-                <a:ea typeface="Calibri" pitchFamily="34" charset="-122"/>
-                <a:cs typeface="Calibri" pitchFamily="34" charset="-120"/>
+                  <a:srgbClr val="677E5B"/>
+                </a:solidFill>
+                <a:latin typeface="Inter" pitchFamily="34" charset="0"/>
+                <a:ea typeface="Inter" pitchFamily="34" charset="-122"/>
+                <a:cs typeface="Inter" pitchFamily="34" charset="-120"/>
               </a:rPr>
               <a:t>02</a:t>
             </a:r>
@@ -3560,11 +3560,11 @@
             <a:r>
               <a:rPr lang="en-US" sz="1800" b="1" dirty="0">
                 <a:solidFill>
-                  <a:srgbClr val="111827"/>
-                </a:solidFill>
-                <a:latin typeface="Calibri" pitchFamily="34" charset="0"/>
-                <a:ea typeface="Calibri" pitchFamily="34" charset="-122"/>
-                <a:cs typeface="Calibri" pitchFamily="34" charset="-120"/>
+                  <a:srgbClr val="0F0F0F"/>
+                </a:solidFill>
+                <a:latin typeface="Inter" pitchFamily="34" charset="0"/>
+                <a:ea typeface="Inter" pitchFamily="34" charset="-122"/>
+                <a:cs typeface="Inter" pitchFamily="34" charset="-120"/>
               </a:rPr>
               <a:t>Leistungen</a:t>
             </a:r>
@@ -3599,11 +3599,11 @@
             <a:r>
               <a:rPr lang="en-US" sz="1200" dirty="0">
                 <a:solidFill>
-                  <a:srgbClr val="6B7280"/>
-                </a:solidFill>
-                <a:latin typeface="Calibri" pitchFamily="34" charset="0"/>
-                <a:ea typeface="Calibri" pitchFamily="34" charset="-122"/>
-                <a:cs typeface="Calibri" pitchFamily="34" charset="-120"/>
+                  <a:srgbClr val="5C5C58"/>
+                </a:solidFill>
+                <a:latin typeface="Inter" pitchFamily="34" charset="0"/>
+                <a:ea typeface="Inter" pitchFamily="34" charset="-122"/>
+                <a:cs typeface="Inter" pitchFamily="34" charset="-120"/>
               </a:rPr>
               <a:t>Druckverfahren, Textilien und Veredelung</a:t>
             </a:r>
@@ -3626,11 +3626,11 @@
             <a:avLst/>
           </a:prstGeom>
           <a:solidFill>
-            <a:srgbClr val="E9F9EF"/>
+            <a:srgbClr val="E3ECDD"/>
           </a:solidFill>
           <a:ln w="12700">
             <a:solidFill>
-              <a:srgbClr val="E9F9EF"/>
+              <a:srgbClr val="E3ECDD"/>
             </a:solidFill>
             <a:prstDash val="solid"/>
           </a:ln>
@@ -3687,11 +3687,11 @@
             <a:r>
               <a:rPr lang="en-US" sz="2000" b="1" dirty="0">
                 <a:solidFill>
-                  <a:srgbClr val="15803D"/>
-                </a:solidFill>
-                <a:latin typeface="Calibri" pitchFamily="34" charset="0"/>
-                <a:ea typeface="Calibri" pitchFamily="34" charset="-122"/>
-                <a:cs typeface="Calibri" pitchFamily="34" charset="-120"/>
+                  <a:srgbClr val="677E5B"/>
+                </a:solidFill>
+                <a:latin typeface="Inter" pitchFamily="34" charset="0"/>
+                <a:ea typeface="Inter" pitchFamily="34" charset="-122"/>
+                <a:cs typeface="Inter" pitchFamily="34" charset="-120"/>
               </a:rPr>
               <a:t>03</a:t>
             </a:r>
@@ -3726,11 +3726,11 @@
             <a:r>
               <a:rPr lang="en-US" sz="1800" b="1" dirty="0">
                 <a:solidFill>
-                  <a:srgbClr val="111827"/>
-                </a:solidFill>
-                <a:latin typeface="Calibri" pitchFamily="34" charset="0"/>
-                <a:ea typeface="Calibri" pitchFamily="34" charset="-122"/>
-                <a:cs typeface="Calibri" pitchFamily="34" charset="-120"/>
+                  <a:srgbClr val="0F0F0F"/>
+                </a:solidFill>
+                <a:latin typeface="Inter" pitchFamily="34" charset="0"/>
+                <a:ea typeface="Inter" pitchFamily="34" charset="-122"/>
+                <a:cs typeface="Inter" pitchFamily="34" charset="-120"/>
               </a:rPr>
               <a:t>Ablauf</a:t>
             </a:r>
@@ -3765,11 +3765,11 @@
             <a:r>
               <a:rPr lang="en-US" sz="1200" dirty="0">
                 <a:solidFill>
-                  <a:srgbClr val="6B7280"/>
-                </a:solidFill>
-                <a:latin typeface="Calibri" pitchFamily="34" charset="0"/>
-                <a:ea typeface="Calibri" pitchFamily="34" charset="-122"/>
-                <a:cs typeface="Calibri" pitchFamily="34" charset="-120"/>
+                  <a:srgbClr val="5C5C58"/>
+                </a:solidFill>
+                <a:latin typeface="Inter" pitchFamily="34" charset="0"/>
+                <a:ea typeface="Inter" pitchFamily="34" charset="-122"/>
+                <a:cs typeface="Inter" pitchFamily="34" charset="-120"/>
               </a:rPr>
               <a:t>Von der Anfrage bis zur Lieferung</a:t>
             </a:r>
@@ -3792,11 +3792,11 @@
             <a:avLst/>
           </a:prstGeom>
           <a:solidFill>
-            <a:srgbClr val="E9F9EF"/>
+            <a:srgbClr val="E3ECDD"/>
           </a:solidFill>
           <a:ln w="12700">
             <a:solidFill>
-              <a:srgbClr val="E9F9EF"/>
+              <a:srgbClr val="E3ECDD"/>
             </a:solidFill>
             <a:prstDash val="solid"/>
           </a:ln>
@@ -3853,11 +3853,11 @@
             <a:r>
               <a:rPr lang="en-US" sz="2000" b="1" dirty="0">
                 <a:solidFill>
-                  <a:srgbClr val="15803D"/>
-                </a:solidFill>
-                <a:latin typeface="Calibri" pitchFamily="34" charset="0"/>
-                <a:ea typeface="Calibri" pitchFamily="34" charset="-122"/>
-                <a:cs typeface="Calibri" pitchFamily="34" charset="-120"/>
+                  <a:srgbClr val="677E5B"/>
+                </a:solidFill>
+                <a:latin typeface="Inter" pitchFamily="34" charset="0"/>
+                <a:ea typeface="Inter" pitchFamily="34" charset="-122"/>
+                <a:cs typeface="Inter" pitchFamily="34" charset="-120"/>
               </a:rPr>
               <a:t>04</a:t>
             </a:r>
@@ -3892,11 +3892,11 @@
             <a:r>
               <a:rPr lang="en-US" sz="1800" b="1" dirty="0">
                 <a:solidFill>
-                  <a:srgbClr val="111827"/>
-                </a:solidFill>
-                <a:latin typeface="Calibri" pitchFamily="34" charset="0"/>
-                <a:ea typeface="Calibri" pitchFamily="34" charset="-122"/>
-                <a:cs typeface="Calibri" pitchFamily="34" charset="-120"/>
+                  <a:srgbClr val="0F0F0F"/>
+                </a:solidFill>
+                <a:latin typeface="Inter" pitchFamily="34" charset="0"/>
+                <a:ea typeface="Inter" pitchFamily="34" charset="-122"/>
+                <a:cs typeface="Inter" pitchFamily="34" charset="-120"/>
               </a:rPr>
               <a:t>Angebot</a:t>
             </a:r>
@@ -3931,11 +3931,11 @@
             <a:r>
               <a:rPr lang="en-US" sz="1200" dirty="0">
                 <a:solidFill>
-                  <a:srgbClr val="6B7280"/>
-                </a:solidFill>
-                <a:latin typeface="Calibri" pitchFamily="34" charset="0"/>
-                <a:ea typeface="Calibri" pitchFamily="34" charset="-122"/>
-                <a:cs typeface="Calibri" pitchFamily="34" charset="-120"/>
+                  <a:srgbClr val="5C5C58"/>
+                </a:solidFill>
+                <a:latin typeface="Inter" pitchFamily="34" charset="0"/>
+                <a:ea typeface="Inter" pitchFamily="34" charset="-122"/>
+                <a:cs typeface="Inter" pitchFamily="34" charset="-120"/>
               </a:rPr>
               <a:t>Positionen, Preise und nächste Schritte</a:t>
             </a:r>
@@ -3973,11 +3973,11 @@
             <a:lvl1pPr>
               <a:defRPr sz="900">
                 <a:solidFill>
-                  <a:srgbClr val="6B7280"/>
-                </a:solidFill>
-                <a:latin typeface="Calibri"/>
-                <a:ea typeface="Calibri"/>
-                <a:cs typeface="Calibri"/>
+                  <a:srgbClr val="5C5C58"/>
+                </a:solidFill>
+                <a:latin typeface="Inter"/>
+                <a:ea typeface="Inter"/>
+                <a:cs typeface="Inter"/>
               </a:defRPr>
             </a:lvl1pPr>
           </a:lstStyle>
@@ -4045,11 +4045,11 @@
             <a:r>
               <a:rPr lang="en-US" sz="5400" b="1" dirty="0">
                 <a:solidFill>
-                  <a:srgbClr val="22C55E"/>
-                </a:solidFill>
-                <a:latin typeface="Calibri" pitchFamily="34" charset="0"/>
-                <a:ea typeface="Calibri" pitchFamily="34" charset="-122"/>
-                <a:cs typeface="Calibri" pitchFamily="34" charset="-120"/>
+                  <a:srgbClr val="819E72"/>
+                </a:solidFill>
+                <a:latin typeface="Inter" pitchFamily="34" charset="0"/>
+                <a:ea typeface="Inter" pitchFamily="34" charset="-122"/>
+                <a:cs typeface="Inter" pitchFamily="34" charset="-120"/>
               </a:rPr>
               <a:t>01</a:t>
             </a:r>
@@ -4088,9 +4088,9 @@
                 <a:solidFill>
                   <a:srgbClr val="FFFFFF"/>
                 </a:solidFill>
-                <a:latin typeface="Calibri" pitchFamily="34" charset="0"/>
-                <a:ea typeface="Calibri" pitchFamily="34" charset="-122"/>
-                <a:cs typeface="Calibri" pitchFamily="34" charset="-120"/>
+                <a:latin typeface="Inter" pitchFamily="34" charset="0"/>
+                <a:ea typeface="Inter" pitchFamily="34" charset="-122"/>
+                <a:cs typeface="Inter" pitchFamily="34" charset="-120"/>
               </a:rPr>
               <a:t>Über uns</a:t>
             </a:r>
@@ -4127,11 +4127,11 @@
             <a:r>
               <a:rPr lang="en-US" sz="1600" dirty="0">
                 <a:solidFill>
-                  <a:srgbClr val="9AA4B2"/>
-                </a:solidFill>
-                <a:latin typeface="Calibri" pitchFamily="34" charset="0"/>
-                <a:ea typeface="Calibri" pitchFamily="34" charset="-122"/>
-                <a:cs typeface="Calibri" pitchFamily="34" charset="-120"/>
+                  <a:srgbClr val="CFC8BB"/>
+                </a:solidFill>
+                <a:latin typeface="Inter" pitchFamily="34" charset="0"/>
+                <a:ea typeface="Inter" pitchFamily="34" charset="-122"/>
+                <a:cs typeface="Inter" pitchFamily="34" charset="-120"/>
               </a:rPr>
               <a:t>Textilveredelung aus einer Hand – persönlich, schnell und in gleichbleibender Qualität</a:t>
             </a:r>
@@ -4175,7 +4175,7 @@
         <p:spPr>
           <a:xfrm>
             <a:off x="457200" y="320040"/>
-            <a:ext cx="6217920" cy="685800"/>
+            <a:ext cx="6858000" cy="685800"/>
           </a:xfrm>
           <a:prstGeom prst="rect">
             <a:avLst/>
@@ -4193,11 +4193,11 @@
             <a:r>
               <a:rPr lang="en-US" sz="2800" b="1" dirty="0">
                 <a:solidFill>
-                  <a:srgbClr val="111827"/>
-                </a:solidFill>
-                <a:latin typeface="Calibri" pitchFamily="34" charset="0"/>
-                <a:ea typeface="Calibri" pitchFamily="34" charset="-122"/>
-                <a:cs typeface="Calibri" pitchFamily="34" charset="-120"/>
+                  <a:srgbClr val="0F0F0F"/>
+                </a:solidFill>
+                <a:latin typeface="Inter" pitchFamily="34" charset="0"/>
+                <a:ea typeface="Inter" pitchFamily="34" charset="-122"/>
+                <a:cs typeface="Inter" pitchFamily="34" charset="-120"/>
               </a:rPr>
               <a:t>Was uns ausmacht</a:t>
             </a:r>
@@ -4232,11 +4232,11 @@
             <a:r>
               <a:rPr lang="en-US" sz="1400" dirty="0">
                 <a:solidFill>
-                  <a:srgbClr val="111827"/>
-                </a:solidFill>
-                <a:latin typeface="Calibri" pitchFamily="34" charset="0"/>
-                <a:ea typeface="Calibri" pitchFamily="34" charset="-122"/>
-                <a:cs typeface="Calibri" pitchFamily="34" charset="-120"/>
+                  <a:srgbClr val="0F0F0F"/>
+                </a:solidFill>
+                <a:latin typeface="Inter" pitchFamily="34" charset="0"/>
+                <a:ea typeface="Inter" pitchFamily="34" charset="-122"/>
+                <a:cs typeface="Inter" pitchFamily="34" charset="-120"/>
               </a:rPr>
               <a:t>Maiershirts veredelt Textilien für Unternehmen, Vereine und Events. Vom einzelnen Shirt bis zur kompletten Teamausstattung begleiten wir jedes Projekt persönlich – von der Motividee bis zum fertigen Paket.</a:t>
             </a:r>
@@ -4275,11 +4275,11 @@
             <a:r>
               <a:rPr lang="en-US" sz="1400" dirty="0">
                 <a:solidFill>
-                  <a:srgbClr val="111827"/>
-                </a:solidFill>
-                <a:latin typeface="Calibri" pitchFamily="34" charset="0"/>
-                <a:ea typeface="Calibri" pitchFamily="34" charset="-122"/>
-                <a:cs typeface="Calibri" pitchFamily="34" charset="-120"/>
+                  <a:srgbClr val="0F0F0F"/>
+                </a:solidFill>
+                <a:latin typeface="Inter" pitchFamily="34" charset="0"/>
+                <a:ea typeface="Inter" pitchFamily="34" charset="-122"/>
+                <a:cs typeface="Inter" pitchFamily="34" charset="-120"/>
               </a:rPr>
               <a:t>Beratung zu Textil, Verfahren und Motiv</a:t>
             </a:r>
@@ -4296,11 +4296,11 @@
             <a:r>
               <a:rPr lang="en-US" sz="1400" dirty="0">
                 <a:solidFill>
-                  <a:srgbClr val="111827"/>
-                </a:solidFill>
-                <a:latin typeface="Calibri" pitchFamily="34" charset="0"/>
-                <a:ea typeface="Calibri" pitchFamily="34" charset="-122"/>
-                <a:cs typeface="Calibri" pitchFamily="34" charset="-120"/>
+                  <a:srgbClr val="0F0F0F"/>
+                </a:solidFill>
+                <a:latin typeface="Inter" pitchFamily="34" charset="0"/>
+                <a:ea typeface="Inter" pitchFamily="34" charset="-122"/>
+                <a:cs typeface="Inter" pitchFamily="34" charset="-120"/>
               </a:rPr>
               <a:t>Druck und Stickerei im eigenen Haus</a:t>
             </a:r>
@@ -4317,11 +4317,11 @@
             <a:r>
               <a:rPr lang="en-US" sz="1400" dirty="0">
                 <a:solidFill>
-                  <a:srgbClr val="111827"/>
-                </a:solidFill>
-                <a:latin typeface="Calibri" pitchFamily="34" charset="0"/>
-                <a:ea typeface="Calibri" pitchFamily="34" charset="-122"/>
-                <a:cs typeface="Calibri" pitchFamily="34" charset="-120"/>
+                  <a:srgbClr val="0F0F0F"/>
+                </a:solidFill>
+                <a:latin typeface="Inter" pitchFamily="34" charset="0"/>
+                <a:ea typeface="Inter" pitchFamily="34" charset="-122"/>
+                <a:cs typeface="Inter" pitchFamily="34" charset="-120"/>
               </a:rPr>
               <a:t>Kleine Auflagen ab 1 Stück</a:t>
             </a:r>
@@ -4338,11 +4338,11 @@
             <a:r>
               <a:rPr lang="en-US" sz="1400" dirty="0">
                 <a:solidFill>
-                  <a:srgbClr val="111827"/>
-                </a:solidFill>
-                <a:latin typeface="Calibri" pitchFamily="34" charset="0"/>
-                <a:ea typeface="Calibri" pitchFamily="34" charset="-122"/>
-                <a:cs typeface="Calibri" pitchFamily="34" charset="-120"/>
+                  <a:srgbClr val="0F0F0F"/>
+                </a:solidFill>
+                <a:latin typeface="Inter" pitchFamily="34" charset="0"/>
+                <a:ea typeface="Inter" pitchFamily="34" charset="-122"/>
+                <a:cs typeface="Inter" pitchFamily="34" charset="-120"/>
               </a:rPr>
               <a:t>Verlässliche Liefertermine</a:t>
             </a:r>
@@ -4367,11 +4367,11 @@
             </a:avLst>
           </a:prstGeom>
           <a:solidFill>
-            <a:srgbClr val="F3F4F6"/>
+            <a:srgbClr val="E8DFD0"/>
           </a:solidFill>
           <a:ln w="12700">
             <a:solidFill>
-              <a:srgbClr val="F3F4F6"/>
+              <a:srgbClr val="E8DFD0"/>
             </a:solidFill>
             <a:prstDash val="solid"/>
           </a:ln>
@@ -4453,11 +4453,11 @@
             <a:r>
               <a:rPr lang="en-US" sz="1400" b="1" dirty="0">
                 <a:solidFill>
-                  <a:srgbClr val="111827"/>
-                </a:solidFill>
-                <a:latin typeface="Calibri" pitchFamily="34" charset="0"/>
-                <a:ea typeface="Calibri" pitchFamily="34" charset="-122"/>
-                <a:cs typeface="Calibri" pitchFamily="34" charset="-120"/>
+                  <a:srgbClr val="0F0F0F"/>
+                </a:solidFill>
+                <a:latin typeface="Inter" pitchFamily="34" charset="0"/>
+                <a:ea typeface="Inter" pitchFamily="34" charset="-122"/>
+                <a:cs typeface="Inter" pitchFamily="34" charset="-120"/>
               </a:rPr>
               <a:t>Siebdruck</a:t>
             </a:r>
@@ -4492,11 +4492,11 @@
             <a:r>
               <a:rPr lang="en-US" sz="1050" dirty="0">
                 <a:solidFill>
-                  <a:srgbClr val="6B7280"/>
-                </a:solidFill>
-                <a:latin typeface="Calibri" pitchFamily="34" charset="0"/>
-                <a:ea typeface="Calibri" pitchFamily="34" charset="-122"/>
-                <a:cs typeface="Calibri" pitchFamily="34" charset="-120"/>
+                  <a:srgbClr val="5C5C58"/>
+                </a:solidFill>
+                <a:latin typeface="Inter" pitchFamily="34" charset="0"/>
+                <a:ea typeface="Inter" pitchFamily="34" charset="-122"/>
+                <a:cs typeface="Inter" pitchFamily="34" charset="-120"/>
               </a:rPr>
               <a:t>Kräftige Farben, ideal für größere Auflagen</a:t>
             </a:r>
@@ -4521,11 +4521,11 @@
             </a:avLst>
           </a:prstGeom>
           <a:solidFill>
-            <a:srgbClr val="F3F4F6"/>
+            <a:srgbClr val="E8DFD0"/>
           </a:solidFill>
           <a:ln w="12700">
             <a:solidFill>
-              <a:srgbClr val="F3F4F6"/>
+              <a:srgbClr val="E8DFD0"/>
             </a:solidFill>
             <a:prstDash val="solid"/>
           </a:ln>
@@ -4607,11 +4607,11 @@
             <a:r>
               <a:rPr lang="en-US" sz="1400" b="1" dirty="0">
                 <a:solidFill>
-                  <a:srgbClr val="111827"/>
-                </a:solidFill>
-                <a:latin typeface="Calibri" pitchFamily="34" charset="0"/>
-                <a:ea typeface="Calibri" pitchFamily="34" charset="-122"/>
-                <a:cs typeface="Calibri" pitchFamily="34" charset="-120"/>
+                  <a:srgbClr val="0F0F0F"/>
+                </a:solidFill>
+                <a:latin typeface="Inter" pitchFamily="34" charset="0"/>
+                <a:ea typeface="Inter" pitchFamily="34" charset="-122"/>
+                <a:cs typeface="Inter" pitchFamily="34" charset="-120"/>
               </a:rPr>
               <a:t>Stickerei</a:t>
             </a:r>
@@ -4646,11 +4646,11 @@
             <a:r>
               <a:rPr lang="en-US" sz="1050" dirty="0">
                 <a:solidFill>
-                  <a:srgbClr val="6B7280"/>
-                </a:solidFill>
-                <a:latin typeface="Calibri" pitchFamily="34" charset="0"/>
-                <a:ea typeface="Calibri" pitchFamily="34" charset="-122"/>
-                <a:cs typeface="Calibri" pitchFamily="34" charset="-120"/>
+                  <a:srgbClr val="5C5C58"/>
+                </a:solidFill>
+                <a:latin typeface="Inter" pitchFamily="34" charset="0"/>
+                <a:ea typeface="Inter" pitchFamily="34" charset="-122"/>
+                <a:cs typeface="Inter" pitchFamily="34" charset="-120"/>
               </a:rPr>
               <a:t>Hochwertig und langlebig für Workwear</a:t>
             </a:r>
@@ -4675,11 +4675,11 @@
             </a:avLst>
           </a:prstGeom>
           <a:solidFill>
-            <a:srgbClr val="F3F4F6"/>
+            <a:srgbClr val="E8DFD0"/>
           </a:solidFill>
           <a:ln w="12700">
             <a:solidFill>
-              <a:srgbClr val="F3F4F6"/>
+              <a:srgbClr val="E8DFD0"/>
             </a:solidFill>
             <a:prstDash val="solid"/>
           </a:ln>
@@ -4761,11 +4761,11 @@
             <a:r>
               <a:rPr lang="en-US" sz="1400" b="1" dirty="0">
                 <a:solidFill>
-                  <a:srgbClr val="111827"/>
-                </a:solidFill>
-                <a:latin typeface="Calibri" pitchFamily="34" charset="0"/>
-                <a:ea typeface="Calibri" pitchFamily="34" charset="-122"/>
-                <a:cs typeface="Calibri" pitchFamily="34" charset="-120"/>
+                  <a:srgbClr val="0F0F0F"/>
+                </a:solidFill>
+                <a:latin typeface="Inter" pitchFamily="34" charset="0"/>
+                <a:ea typeface="Inter" pitchFamily="34" charset="-122"/>
+                <a:cs typeface="Inter" pitchFamily="34" charset="-120"/>
               </a:rPr>
               <a:t>Express</a:t>
             </a:r>
@@ -4800,11 +4800,11 @@
             <a:r>
               <a:rPr lang="en-US" sz="1050" dirty="0">
                 <a:solidFill>
-                  <a:srgbClr val="6B7280"/>
-                </a:solidFill>
-                <a:latin typeface="Calibri" pitchFamily="34" charset="0"/>
-                <a:ea typeface="Calibri" pitchFamily="34" charset="-122"/>
-                <a:cs typeface="Calibri" pitchFamily="34" charset="-120"/>
+                  <a:srgbClr val="5C5C58"/>
+                </a:solidFill>
+                <a:latin typeface="Inter" pitchFamily="34" charset="0"/>
+                <a:ea typeface="Inter" pitchFamily="34" charset="-122"/>
+                <a:cs typeface="Inter" pitchFamily="34" charset="-120"/>
               </a:rPr>
               <a:t>Kurze Produktionszeiten auf Anfrage</a:t>
             </a:r>
@@ -4829,11 +4829,11 @@
             </a:avLst>
           </a:prstGeom>
           <a:solidFill>
-            <a:srgbClr val="F3F4F6"/>
+            <a:srgbClr val="E8DFD0"/>
           </a:solidFill>
           <a:ln w="12700">
             <a:solidFill>
-              <a:srgbClr val="F3F4F6"/>
+              <a:srgbClr val="E8DFD0"/>
             </a:solidFill>
             <a:prstDash val="solid"/>
           </a:ln>
@@ -4915,11 +4915,11 @@
             <a:r>
               <a:rPr lang="en-US" sz="1400" b="1" dirty="0">
                 <a:solidFill>
-                  <a:srgbClr val="111827"/>
-                </a:solidFill>
-                <a:latin typeface="Calibri" pitchFamily="34" charset="0"/>
-                <a:ea typeface="Calibri" pitchFamily="34" charset="-122"/>
-                <a:cs typeface="Calibri" pitchFamily="34" charset="-120"/>
+                  <a:srgbClr val="0F0F0F"/>
+                </a:solidFill>
+                <a:latin typeface="Inter" pitchFamily="34" charset="0"/>
+                <a:ea typeface="Inter" pitchFamily="34" charset="-122"/>
+                <a:cs typeface="Inter" pitchFamily="34" charset="-120"/>
               </a:rPr>
               <a:t>Qualität</a:t>
             </a:r>
@@ -4954,11 +4954,11 @@
             <a:r>
               <a:rPr lang="en-US" sz="1050" dirty="0">
                 <a:solidFill>
-                  <a:srgbClr val="6B7280"/>
-                </a:solidFill>
-                <a:latin typeface="Calibri" pitchFamily="34" charset="0"/>
-                <a:ea typeface="Calibri" pitchFamily="34" charset="-122"/>
-                <a:cs typeface="Calibri" pitchFamily="34" charset="-120"/>
+                  <a:srgbClr val="5C5C58"/>
+                </a:solidFill>
+                <a:latin typeface="Inter" pitchFamily="34" charset="0"/>
+                <a:ea typeface="Inter" pitchFamily="34" charset="-122"/>
+                <a:cs typeface="Inter" pitchFamily="34" charset="-120"/>
               </a:rPr>
               <a:t>Geprüfte Textilien namhafter Hersteller</a:t>
             </a:r>
@@ -4996,11 +4996,11 @@
             <a:lvl1pPr>
               <a:defRPr sz="900">
                 <a:solidFill>
-                  <a:srgbClr val="6B7280"/>
-                </a:solidFill>
-                <a:latin typeface="Calibri"/>
-                <a:ea typeface="Calibri"/>
-                <a:cs typeface="Calibri"/>
+                  <a:srgbClr val="5C5C58"/>
+                </a:solidFill>
+                <a:latin typeface="Inter"/>
+                <a:ea typeface="Inter"/>
+                <a:cs typeface="Inter"/>
               </a:defRPr>
             </a:lvl1pPr>
           </a:lstStyle>
@@ -5050,7 +5050,7 @@
         <p:spPr>
           <a:xfrm>
             <a:off x="457200" y="320040"/>
-            <a:ext cx="6217920" cy="685800"/>
+            <a:ext cx="6858000" cy="685800"/>
           </a:xfrm>
           <a:prstGeom prst="rect">
             <a:avLst/>
@@ -5068,11 +5068,11 @@
             <a:r>
               <a:rPr lang="en-US" sz="2800" b="1" dirty="0">
                 <a:solidFill>
-                  <a:srgbClr val="111827"/>
-                </a:solidFill>
-                <a:latin typeface="Calibri" pitchFamily="34" charset="0"/>
-                <a:ea typeface="Calibri" pitchFamily="34" charset="-122"/>
-                <a:cs typeface="Calibri" pitchFamily="34" charset="-120"/>
+                  <a:srgbClr val="0F0F0F"/>
+                </a:solidFill>
+                <a:latin typeface="Inter" pitchFamily="34" charset="0"/>
+                <a:ea typeface="Inter" pitchFamily="34" charset="-122"/>
+                <a:cs typeface="Inter" pitchFamily="34" charset="-120"/>
               </a:rPr>
               <a:t>Zahlen, die für uns sprechen</a:t>
             </a:r>
@@ -5097,11 +5097,11 @@
             </a:avLst>
           </a:prstGeom>
           <a:solidFill>
-            <a:srgbClr val="F3F4F6"/>
+            <a:srgbClr val="E8DFD0"/>
           </a:solidFill>
           <a:ln w="12700">
             <a:solidFill>
-              <a:srgbClr val="F3F4F6"/>
+              <a:srgbClr val="E8DFD0"/>
             </a:solidFill>
             <a:prstDash val="solid"/>
           </a:ln>
@@ -5132,17 +5132,17 @@
               <a:buNone/>
             </a:pPr>
             <a:r>
-              <a:rPr lang="en-US" sz="5400" b="1" dirty="0">
-                <a:solidFill>
-                  <a:srgbClr val="15803D"/>
-                </a:solidFill>
-                <a:latin typeface="Calibri" pitchFamily="34" charset="0"/>
-                <a:ea typeface="Calibri" pitchFamily="34" charset="-122"/>
-                <a:cs typeface="Calibri" pitchFamily="34" charset="-120"/>
+              <a:rPr lang="en-US" sz="4400" b="1" dirty="0">
+                <a:solidFill>
+                  <a:srgbClr val="677E5B"/>
+                </a:solidFill>
+                <a:latin typeface="Inter" pitchFamily="34" charset="0"/>
+                <a:ea typeface="Inter" pitchFamily="34" charset="-122"/>
+                <a:cs typeface="Inter" pitchFamily="34" charset="-120"/>
               </a:rPr>
               <a:t>1.200+</a:t>
             </a:r>
-            <a:endParaRPr lang="en-US" sz="5400" dirty="0"/>
+            <a:endParaRPr lang="en-US" sz="4400" dirty="0"/>
           </a:p>
         </p:txBody>
       </p:sp>
@@ -5154,8 +5154,8 @@
         </p:nvSpPr>
         <p:spPr>
           <a:xfrm>
-            <a:off x="685800" y="2697480"/>
-            <a:ext cx="2194560" cy="365760"/>
+            <a:off x="685800" y="2651760"/>
+            <a:ext cx="2194560" cy="594360"/>
           </a:xfrm>
           <a:prstGeom prst="rect">
             <a:avLst/>
@@ -5164,24 +5164,24 @@
           <a:ln/>
         </p:spPr>
         <p:txBody>
-          <a:bodyPr wrap="square" lIns="0" tIns="0" rIns="0" bIns="0" rtlCol="0" anchor="ctr"/>
+          <a:bodyPr wrap="square" lIns="0" tIns="0" rIns="0" bIns="0" rtlCol="0" anchor="t"/>
           <a:lstStyle/>
           <a:p>
             <a:pPr indent="0" marL="0">
               <a:buNone/>
             </a:pPr>
             <a:r>
-              <a:rPr lang="en-US" sz="1500" b="1" dirty="0">
-                <a:solidFill>
-                  <a:srgbClr val="111827"/>
-                </a:solidFill>
-                <a:latin typeface="Calibri" pitchFamily="34" charset="0"/>
-                <a:ea typeface="Calibri" pitchFamily="34" charset="-122"/>
-                <a:cs typeface="Calibri" pitchFamily="34" charset="-120"/>
+              <a:rPr lang="en-US" sz="1400" b="1" dirty="0">
+                <a:solidFill>
+                  <a:srgbClr val="0F0F0F"/>
+                </a:solidFill>
+                <a:latin typeface="Inter" pitchFamily="34" charset="0"/>
+                <a:ea typeface="Inter" pitchFamily="34" charset="-122"/>
+                <a:cs typeface="Inter" pitchFamily="34" charset="-120"/>
               </a:rPr>
               <a:t>Projekte pro Jahr</a:t>
             </a:r>
-            <a:endParaRPr lang="en-US" sz="1500" dirty="0"/>
+            <a:endParaRPr lang="en-US" sz="1400" dirty="0"/>
           </a:p>
         </p:txBody>
       </p:sp>
@@ -5193,7 +5193,7 @@
         </p:nvSpPr>
         <p:spPr>
           <a:xfrm>
-            <a:off x="685800" y="3108960"/>
+            <a:off x="685800" y="3246120"/>
             <a:ext cx="2194560" cy="320040"/>
           </a:xfrm>
           <a:prstGeom prst="rect">
@@ -5212,11 +5212,11 @@
             <a:r>
               <a:rPr lang="en-US" sz="1100" i="1" dirty="0">
                 <a:solidFill>
-                  <a:srgbClr val="6B7280"/>
-                </a:solidFill>
-                <a:latin typeface="Calibri" pitchFamily="34" charset="0"/>
-                <a:ea typeface="Calibri" pitchFamily="34" charset="-122"/>
-                <a:cs typeface="Calibri" pitchFamily="34" charset="-120"/>
+                  <a:srgbClr val="5C5C58"/>
+                </a:solidFill>
+                <a:latin typeface="Inter" pitchFamily="34" charset="0"/>
+                <a:ea typeface="Inter" pitchFamily="34" charset="-122"/>
+                <a:cs typeface="Inter" pitchFamily="34" charset="-120"/>
               </a:rPr>
               <a:t>Beispielwert</a:t>
             </a:r>
@@ -5241,11 +5241,11 @@
             </a:avLst>
           </a:prstGeom>
           <a:solidFill>
-            <a:srgbClr val="F3F4F6"/>
+            <a:srgbClr val="E8DFD0"/>
           </a:solidFill>
           <a:ln w="12700">
             <a:solidFill>
-              <a:srgbClr val="F3F4F6"/>
+              <a:srgbClr val="E8DFD0"/>
             </a:solidFill>
             <a:prstDash val="solid"/>
           </a:ln>
@@ -5276,17 +5276,17 @@
               <a:buNone/>
             </a:pPr>
             <a:r>
-              <a:rPr lang="en-US" sz="5400" b="1" dirty="0">
-                <a:solidFill>
-                  <a:srgbClr val="15803D"/>
-                </a:solidFill>
-                <a:latin typeface="Calibri" pitchFamily="34" charset="0"/>
-                <a:ea typeface="Calibri" pitchFamily="34" charset="-122"/>
-                <a:cs typeface="Calibri" pitchFamily="34" charset="-120"/>
+              <a:rPr lang="en-US" sz="4400" b="1" dirty="0">
+                <a:solidFill>
+                  <a:srgbClr val="677E5B"/>
+                </a:solidFill>
+                <a:latin typeface="Inter" pitchFamily="34" charset="0"/>
+                <a:ea typeface="Inter" pitchFamily="34" charset="-122"/>
+                <a:cs typeface="Inter" pitchFamily="34" charset="-120"/>
               </a:rPr>
               <a:t>48 h</a:t>
             </a:r>
-            <a:endParaRPr lang="en-US" sz="5400" dirty="0"/>
+            <a:endParaRPr lang="en-US" sz="4400" dirty="0"/>
           </a:p>
         </p:txBody>
       </p:sp>
@@ -5298,8 +5298,8 @@
         </p:nvSpPr>
         <p:spPr>
           <a:xfrm>
-            <a:off x="3474720" y="2697480"/>
-            <a:ext cx="2194560" cy="365760"/>
+            <a:off x="3474720" y="2651760"/>
+            <a:ext cx="2194560" cy="594360"/>
           </a:xfrm>
           <a:prstGeom prst="rect">
             <a:avLst/>
@@ -5308,24 +5308,24 @@
           <a:ln/>
         </p:spPr>
         <p:txBody>
-          <a:bodyPr wrap="square" lIns="0" tIns="0" rIns="0" bIns="0" rtlCol="0" anchor="ctr"/>
+          <a:bodyPr wrap="square" lIns="0" tIns="0" rIns="0" bIns="0" rtlCol="0" anchor="t"/>
           <a:lstStyle/>
           <a:p>
             <a:pPr indent="0" marL="0">
               <a:buNone/>
             </a:pPr>
             <a:r>
-              <a:rPr lang="en-US" sz="1500" b="1" dirty="0">
-                <a:solidFill>
-                  <a:srgbClr val="111827"/>
-                </a:solidFill>
-                <a:latin typeface="Calibri" pitchFamily="34" charset="0"/>
-                <a:ea typeface="Calibri" pitchFamily="34" charset="-122"/>
-                <a:cs typeface="Calibri" pitchFamily="34" charset="-120"/>
+              <a:rPr lang="en-US" sz="1400" b="1" dirty="0">
+                <a:solidFill>
+                  <a:srgbClr val="0F0F0F"/>
+                </a:solidFill>
+                <a:latin typeface="Inter" pitchFamily="34" charset="0"/>
+                <a:ea typeface="Inter" pitchFamily="34" charset="-122"/>
+                <a:cs typeface="Inter" pitchFamily="34" charset="-120"/>
               </a:rPr>
               <a:t>Angebot in Arbeitstagen</a:t>
             </a:r>
-            <a:endParaRPr lang="en-US" sz="1500" dirty="0"/>
+            <a:endParaRPr lang="en-US" sz="1400" dirty="0"/>
           </a:p>
         </p:txBody>
       </p:sp>
@@ -5337,7 +5337,7 @@
         </p:nvSpPr>
         <p:spPr>
           <a:xfrm>
-            <a:off x="3474720" y="3108960"/>
+            <a:off x="3474720" y="3246120"/>
             <a:ext cx="2194560" cy="320040"/>
           </a:xfrm>
           <a:prstGeom prst="rect">
@@ -5356,11 +5356,11 @@
             <a:r>
               <a:rPr lang="en-US" sz="1100" i="1" dirty="0">
                 <a:solidFill>
-                  <a:srgbClr val="6B7280"/>
-                </a:solidFill>
-                <a:latin typeface="Calibri" pitchFamily="34" charset="0"/>
-                <a:ea typeface="Calibri" pitchFamily="34" charset="-122"/>
-                <a:cs typeface="Calibri" pitchFamily="34" charset="-120"/>
+                  <a:srgbClr val="5C5C58"/>
+                </a:solidFill>
+                <a:latin typeface="Inter" pitchFamily="34" charset="0"/>
+                <a:ea typeface="Inter" pitchFamily="34" charset="-122"/>
+                <a:cs typeface="Inter" pitchFamily="34" charset="-120"/>
               </a:rPr>
               <a:t>Beispielwert</a:t>
             </a:r>
@@ -5385,11 +5385,11 @@
             </a:avLst>
           </a:prstGeom>
           <a:solidFill>
-            <a:srgbClr val="F3F4F6"/>
+            <a:srgbClr val="E8DFD0"/>
           </a:solidFill>
           <a:ln w="12700">
             <a:solidFill>
-              <a:srgbClr val="F3F4F6"/>
+              <a:srgbClr val="E8DFD0"/>
             </a:solidFill>
             <a:prstDash val="solid"/>
           </a:ln>
@@ -5420,17 +5420,17 @@
               <a:buNone/>
             </a:pPr>
             <a:r>
-              <a:rPr lang="en-US" sz="5400" b="1" dirty="0">
-                <a:solidFill>
-                  <a:srgbClr val="15803D"/>
-                </a:solidFill>
-                <a:latin typeface="Calibri" pitchFamily="34" charset="0"/>
-                <a:ea typeface="Calibri" pitchFamily="34" charset="-122"/>
-                <a:cs typeface="Calibri" pitchFamily="34" charset="-120"/>
+              <a:rPr lang="en-US" sz="4400" b="1" dirty="0">
+                <a:solidFill>
+                  <a:srgbClr val="677E5B"/>
+                </a:solidFill>
+                <a:latin typeface="Inter" pitchFamily="34" charset="0"/>
+                <a:ea typeface="Inter" pitchFamily="34" charset="-122"/>
+                <a:cs typeface="Inter" pitchFamily="34" charset="-120"/>
               </a:rPr>
               <a:t>98 %</a:t>
             </a:r>
-            <a:endParaRPr lang="en-US" sz="5400" dirty="0"/>
+            <a:endParaRPr lang="en-US" sz="4400" dirty="0"/>
           </a:p>
         </p:txBody>
       </p:sp>
@@ -5442,8 +5442,8 @@
         </p:nvSpPr>
         <p:spPr>
           <a:xfrm>
-            <a:off x="6263640" y="2697480"/>
-            <a:ext cx="2194560" cy="365760"/>
+            <a:off x="6263640" y="2651760"/>
+            <a:ext cx="2194560" cy="594360"/>
           </a:xfrm>
           <a:prstGeom prst="rect">
             <a:avLst/>
@@ -5452,24 +5452,24 @@
           <a:ln/>
         </p:spPr>
         <p:txBody>
-          <a:bodyPr wrap="square" lIns="0" tIns="0" rIns="0" bIns="0" rtlCol="0" anchor="ctr"/>
+          <a:bodyPr wrap="square" lIns="0" tIns="0" rIns="0" bIns="0" rtlCol="0" anchor="t"/>
           <a:lstStyle/>
           <a:p>
             <a:pPr indent="0" marL="0">
               <a:buNone/>
             </a:pPr>
             <a:r>
-              <a:rPr lang="en-US" sz="1500" b="1" dirty="0">
-                <a:solidFill>
-                  <a:srgbClr val="111827"/>
-                </a:solidFill>
-                <a:latin typeface="Calibri" pitchFamily="34" charset="0"/>
-                <a:ea typeface="Calibri" pitchFamily="34" charset="-122"/>
-                <a:cs typeface="Calibri" pitchFamily="34" charset="-120"/>
+              <a:rPr lang="en-US" sz="1400" b="1" dirty="0">
+                <a:solidFill>
+                  <a:srgbClr val="0F0F0F"/>
+                </a:solidFill>
+                <a:latin typeface="Inter" pitchFamily="34" charset="0"/>
+                <a:ea typeface="Inter" pitchFamily="34" charset="-122"/>
+                <a:cs typeface="Inter" pitchFamily="34" charset="-120"/>
               </a:rPr>
               <a:t>Wiederkehrende Kunden</a:t>
             </a:r>
-            <a:endParaRPr lang="en-US" sz="1500" dirty="0"/>
+            <a:endParaRPr lang="en-US" sz="1400" dirty="0"/>
           </a:p>
         </p:txBody>
       </p:sp>
@@ -5481,7 +5481,7 @@
         </p:nvSpPr>
         <p:spPr>
           <a:xfrm>
-            <a:off x="6263640" y="3108960"/>
+            <a:off x="6263640" y="3246120"/>
             <a:ext cx="2194560" cy="320040"/>
           </a:xfrm>
           <a:prstGeom prst="rect">
@@ -5500,11 +5500,11 @@
             <a:r>
               <a:rPr lang="en-US" sz="1100" i="1" dirty="0">
                 <a:solidFill>
-                  <a:srgbClr val="6B7280"/>
-                </a:solidFill>
-                <a:latin typeface="Calibri" pitchFamily="34" charset="0"/>
-                <a:ea typeface="Calibri" pitchFamily="34" charset="-122"/>
-                <a:cs typeface="Calibri" pitchFamily="34" charset="-120"/>
+                  <a:srgbClr val="5C5C58"/>
+                </a:solidFill>
+                <a:latin typeface="Inter" pitchFamily="34" charset="0"/>
+                <a:ea typeface="Inter" pitchFamily="34" charset="-122"/>
+                <a:cs typeface="Inter" pitchFamily="34" charset="-120"/>
               </a:rPr>
               <a:t>Beispielwert</a:t>
             </a:r>
@@ -5539,11 +5539,11 @@
             <a:r>
               <a:rPr lang="en-US" sz="1100" dirty="0">
                 <a:solidFill>
-                  <a:srgbClr val="6B7280"/>
-                </a:solidFill>
-                <a:latin typeface="Calibri" pitchFamily="34" charset="0"/>
-                <a:ea typeface="Calibri" pitchFamily="34" charset="-122"/>
-                <a:cs typeface="Calibri" pitchFamily="34" charset="-120"/>
+                  <a:srgbClr val="5C5C58"/>
+                </a:solidFill>
+                <a:latin typeface="Inter" pitchFamily="34" charset="0"/>
+                <a:ea typeface="Inter" pitchFamily="34" charset="-122"/>
+                <a:cs typeface="Inter" pitchFamily="34" charset="-120"/>
               </a:rPr>
               <a:t>Alle Werte sind Platzhalter und werden vor Verwendung durch echte Kennzahlen ersetzt.</a:t>
             </a:r>
@@ -5581,11 +5581,11 @@
             <a:lvl1pPr>
               <a:defRPr sz="900">
                 <a:solidFill>
-                  <a:srgbClr val="6B7280"/>
-                </a:solidFill>
-                <a:latin typeface="Calibri"/>
-                <a:ea typeface="Calibri"/>
-                <a:cs typeface="Calibri"/>
+                  <a:srgbClr val="5C5C58"/>
+                </a:solidFill>
+                <a:latin typeface="Inter"/>
+                <a:ea typeface="Inter"/>
+                <a:cs typeface="Inter"/>
               </a:defRPr>
             </a:lvl1pPr>
           </a:lstStyle>
@@ -5635,7 +5635,7 @@
         <p:spPr>
           <a:xfrm>
             <a:off x="457200" y="320040"/>
-            <a:ext cx="6217920" cy="685800"/>
+            <a:ext cx="6858000" cy="685800"/>
           </a:xfrm>
           <a:prstGeom prst="rect">
             <a:avLst/>
@@ -5653,11 +5653,11 @@
             <a:r>
               <a:rPr lang="en-US" sz="2800" b="1" dirty="0">
                 <a:solidFill>
-                  <a:srgbClr val="111827"/>
-                </a:solidFill>
-                <a:latin typeface="Calibri" pitchFamily="34" charset="0"/>
-                <a:ea typeface="Calibri" pitchFamily="34" charset="-122"/>
-                <a:cs typeface="Calibri" pitchFamily="34" charset="-120"/>
+                  <a:srgbClr val="0F0F0F"/>
+                </a:solidFill>
+                <a:latin typeface="Inter" pitchFamily="34" charset="0"/>
+                <a:ea typeface="Inter" pitchFamily="34" charset="-122"/>
+                <a:cs typeface="Inter" pitchFamily="34" charset="-120"/>
               </a:rPr>
               <a:t>So läuft ein Auftrag ab</a:t>
             </a:r>
@@ -5682,7 +5682,7 @@
           <a:noFill/>
           <a:ln w="25400">
             <a:solidFill>
-              <a:srgbClr val="E5E7EB"/>
+              <a:srgbClr val="A3C095"/>
             </a:solidFill>
             <a:prstDash val="solid"/>
             <a:tailEnd type="triangle"/>
@@ -5704,11 +5704,11 @@
             <a:avLst/>
           </a:prstGeom>
           <a:solidFill>
-            <a:srgbClr val="E9F9EF"/>
+            <a:srgbClr val="E3ECDD"/>
           </a:solidFill>
           <a:ln w="12700">
             <a:solidFill>
-              <a:srgbClr val="E9F9EF"/>
+              <a:srgbClr val="E3ECDD"/>
             </a:solidFill>
             <a:prstDash val="solid"/>
           </a:ln>
@@ -5753,7 +5753,7 @@
             <a:avLst/>
           </a:prstGeom>
           <a:solidFill>
-            <a:srgbClr val="15803D"/>
+            <a:srgbClr val="677E5B"/>
           </a:solidFill>
           <a:ln/>
         </p:spPr>
@@ -5769,9 +5769,9 @@
                 <a:solidFill>
                   <a:srgbClr val="FFFFFF"/>
                 </a:solidFill>
-                <a:latin typeface="Calibri" pitchFamily="34" charset="0"/>
-                <a:ea typeface="Calibri" pitchFamily="34" charset="-122"/>
-                <a:cs typeface="Calibri" pitchFamily="34" charset="-120"/>
+                <a:latin typeface="Inter" pitchFamily="34" charset="0"/>
+                <a:ea typeface="Inter" pitchFamily="34" charset="-122"/>
+                <a:cs typeface="Inter" pitchFamily="34" charset="-120"/>
               </a:rPr>
               <a:t>1</a:t>
             </a:r>
@@ -5806,11 +5806,11 @@
             <a:r>
               <a:rPr lang="en-US" sz="1600" b="1" dirty="0">
                 <a:solidFill>
-                  <a:srgbClr val="111827"/>
-                </a:solidFill>
-                <a:latin typeface="Calibri" pitchFamily="34" charset="0"/>
-                <a:ea typeface="Calibri" pitchFamily="34" charset="-122"/>
-                <a:cs typeface="Calibri" pitchFamily="34" charset="-120"/>
+                  <a:srgbClr val="0F0F0F"/>
+                </a:solidFill>
+                <a:latin typeface="Inter" pitchFamily="34" charset="0"/>
+                <a:ea typeface="Inter" pitchFamily="34" charset="-122"/>
+                <a:cs typeface="Inter" pitchFamily="34" charset="-120"/>
               </a:rPr>
               <a:t>Anfrage</a:t>
             </a:r>
@@ -5845,11 +5845,11 @@
             <a:r>
               <a:rPr lang="en-US" sz="1150" dirty="0">
                 <a:solidFill>
-                  <a:srgbClr val="6B7280"/>
-                </a:solidFill>
-                <a:latin typeface="Calibri" pitchFamily="34" charset="0"/>
-                <a:ea typeface="Calibri" pitchFamily="34" charset="-122"/>
-                <a:cs typeface="Calibri" pitchFamily="34" charset="-120"/>
+                  <a:srgbClr val="5C5C58"/>
+                </a:solidFill>
+                <a:latin typeface="Inter" pitchFamily="34" charset="0"/>
+                <a:ea typeface="Inter" pitchFamily="34" charset="-122"/>
+                <a:cs typeface="Inter" pitchFamily="34" charset="-120"/>
               </a:rPr>
               <a:t>Textil, Menge und Motiv per Mail oder Telefon</a:t>
             </a:r>
@@ -5874,7 +5874,7 @@
           <a:noFill/>
           <a:ln w="25400">
             <a:solidFill>
-              <a:srgbClr val="E5E7EB"/>
+              <a:srgbClr val="A3C095"/>
             </a:solidFill>
             <a:prstDash val="solid"/>
             <a:tailEnd type="triangle"/>
@@ -5896,11 +5896,11 @@
             <a:avLst/>
           </a:prstGeom>
           <a:solidFill>
-            <a:srgbClr val="E9F9EF"/>
+            <a:srgbClr val="E3ECDD"/>
           </a:solidFill>
           <a:ln w="12700">
             <a:solidFill>
-              <a:srgbClr val="E9F9EF"/>
+              <a:srgbClr val="E3ECDD"/>
             </a:solidFill>
             <a:prstDash val="solid"/>
           </a:ln>
@@ -5945,7 +5945,7 @@
             <a:avLst/>
           </a:prstGeom>
           <a:solidFill>
-            <a:srgbClr val="15803D"/>
+            <a:srgbClr val="677E5B"/>
           </a:solidFill>
           <a:ln/>
         </p:spPr>
@@ -5961,9 +5961,9 @@
                 <a:solidFill>
                   <a:srgbClr val="FFFFFF"/>
                 </a:solidFill>
-                <a:latin typeface="Calibri" pitchFamily="34" charset="0"/>
-                <a:ea typeface="Calibri" pitchFamily="34" charset="-122"/>
-                <a:cs typeface="Calibri" pitchFamily="34" charset="-120"/>
+                <a:latin typeface="Inter" pitchFamily="34" charset="0"/>
+                <a:ea typeface="Inter" pitchFamily="34" charset="-122"/>
+                <a:cs typeface="Inter" pitchFamily="34" charset="-120"/>
               </a:rPr>
               <a:t>2</a:t>
             </a:r>
@@ -5998,11 +5998,11 @@
             <a:r>
               <a:rPr lang="en-US" sz="1600" b="1" dirty="0">
                 <a:solidFill>
-                  <a:srgbClr val="111827"/>
-                </a:solidFill>
-                <a:latin typeface="Calibri" pitchFamily="34" charset="0"/>
-                <a:ea typeface="Calibri" pitchFamily="34" charset="-122"/>
-                <a:cs typeface="Calibri" pitchFamily="34" charset="-120"/>
+                  <a:srgbClr val="0F0F0F"/>
+                </a:solidFill>
+                <a:latin typeface="Inter" pitchFamily="34" charset="0"/>
+                <a:ea typeface="Inter" pitchFamily="34" charset="-122"/>
+                <a:cs typeface="Inter" pitchFamily="34" charset="-120"/>
               </a:rPr>
               <a:t>Angebot</a:t>
             </a:r>
@@ -6037,11 +6037,11 @@
             <a:r>
               <a:rPr lang="en-US" sz="1150" dirty="0">
                 <a:solidFill>
-                  <a:srgbClr val="6B7280"/>
-                </a:solidFill>
-                <a:latin typeface="Calibri" pitchFamily="34" charset="0"/>
-                <a:ea typeface="Calibri" pitchFamily="34" charset="-122"/>
-                <a:cs typeface="Calibri" pitchFamily="34" charset="-120"/>
+                  <a:srgbClr val="5C5C58"/>
+                </a:solidFill>
+                <a:latin typeface="Inter" pitchFamily="34" charset="0"/>
+                <a:ea typeface="Inter" pitchFamily="34" charset="-122"/>
+                <a:cs typeface="Inter" pitchFamily="34" charset="-120"/>
               </a:rPr>
               <a:t>Angebot aus Lexware innerhalb von 48 h</a:t>
             </a:r>
@@ -6066,7 +6066,7 @@
           <a:noFill/>
           <a:ln w="25400">
             <a:solidFill>
-              <a:srgbClr val="E5E7EB"/>
+              <a:srgbClr val="A3C095"/>
             </a:solidFill>
             <a:prstDash val="solid"/>
             <a:tailEnd type="triangle"/>
@@ -6088,11 +6088,11 @@
             <a:avLst/>
           </a:prstGeom>
           <a:solidFill>
-            <a:srgbClr val="E9F9EF"/>
+            <a:srgbClr val="E3ECDD"/>
           </a:solidFill>
           <a:ln w="12700">
             <a:solidFill>
-              <a:srgbClr val="E9F9EF"/>
+              <a:srgbClr val="E3ECDD"/>
             </a:solidFill>
             <a:prstDash val="solid"/>
           </a:ln>
@@ -6137,7 +6137,7 @@
             <a:avLst/>
           </a:prstGeom>
           <a:solidFill>
-            <a:srgbClr val="15803D"/>
+            <a:srgbClr val="677E5B"/>
           </a:solidFill>
           <a:ln/>
         </p:spPr>
@@ -6153,9 +6153,9 @@
                 <a:solidFill>
                   <a:srgbClr val="FFFFFF"/>
                 </a:solidFill>
-                <a:latin typeface="Calibri" pitchFamily="34" charset="0"/>
-                <a:ea typeface="Calibri" pitchFamily="34" charset="-122"/>
-                <a:cs typeface="Calibri" pitchFamily="34" charset="-120"/>
+                <a:latin typeface="Inter" pitchFamily="34" charset="0"/>
+                <a:ea typeface="Inter" pitchFamily="34" charset="-122"/>
+                <a:cs typeface="Inter" pitchFamily="34" charset="-120"/>
               </a:rPr>
               <a:t>3</a:t>
             </a:r>
@@ -6190,11 +6190,11 @@
             <a:r>
               <a:rPr lang="en-US" sz="1600" b="1" dirty="0">
                 <a:solidFill>
-                  <a:srgbClr val="111827"/>
-                </a:solidFill>
-                <a:latin typeface="Calibri" pitchFamily="34" charset="0"/>
-                <a:ea typeface="Calibri" pitchFamily="34" charset="-122"/>
-                <a:cs typeface="Calibri" pitchFamily="34" charset="-120"/>
+                  <a:srgbClr val="0F0F0F"/>
+                </a:solidFill>
+                <a:latin typeface="Inter" pitchFamily="34" charset="0"/>
+                <a:ea typeface="Inter" pitchFamily="34" charset="-122"/>
+                <a:cs typeface="Inter" pitchFamily="34" charset="-120"/>
               </a:rPr>
               <a:t>Produktion</a:t>
             </a:r>
@@ -6229,11 +6229,11 @@
             <a:r>
               <a:rPr lang="en-US" sz="1150" dirty="0">
                 <a:solidFill>
-                  <a:srgbClr val="6B7280"/>
-                </a:solidFill>
-                <a:latin typeface="Calibri" pitchFamily="34" charset="0"/>
-                <a:ea typeface="Calibri" pitchFamily="34" charset="-122"/>
-                <a:cs typeface="Calibri" pitchFamily="34" charset="-120"/>
+                  <a:srgbClr val="5C5C58"/>
+                </a:solidFill>
+                <a:latin typeface="Inter" pitchFamily="34" charset="0"/>
+                <a:ea typeface="Inter" pitchFamily="34" charset="-122"/>
+                <a:cs typeface="Inter" pitchFamily="34" charset="-120"/>
               </a:rPr>
               <a:t>Druck oder Stickerei nach Freigabe</a:t>
             </a:r>
@@ -6256,11 +6256,11 @@
             <a:avLst/>
           </a:prstGeom>
           <a:solidFill>
-            <a:srgbClr val="E9F9EF"/>
+            <a:srgbClr val="E3ECDD"/>
           </a:solidFill>
           <a:ln w="12700">
             <a:solidFill>
-              <a:srgbClr val="E9F9EF"/>
+              <a:srgbClr val="E3ECDD"/>
             </a:solidFill>
             <a:prstDash val="solid"/>
           </a:ln>
@@ -6305,7 +6305,7 @@
             <a:avLst/>
           </a:prstGeom>
           <a:solidFill>
-            <a:srgbClr val="15803D"/>
+            <a:srgbClr val="677E5B"/>
           </a:solidFill>
           <a:ln/>
         </p:spPr>
@@ -6321,9 +6321,9 @@
                 <a:solidFill>
                   <a:srgbClr val="FFFFFF"/>
                 </a:solidFill>
-                <a:latin typeface="Calibri" pitchFamily="34" charset="0"/>
-                <a:ea typeface="Calibri" pitchFamily="34" charset="-122"/>
-                <a:cs typeface="Calibri" pitchFamily="34" charset="-120"/>
+                <a:latin typeface="Inter" pitchFamily="34" charset="0"/>
+                <a:ea typeface="Inter" pitchFamily="34" charset="-122"/>
+                <a:cs typeface="Inter" pitchFamily="34" charset="-120"/>
               </a:rPr>
               <a:t>4</a:t>
             </a:r>
@@ -6358,11 +6358,11 @@
             <a:r>
               <a:rPr lang="en-US" sz="1600" b="1" dirty="0">
                 <a:solidFill>
-                  <a:srgbClr val="111827"/>
-                </a:solidFill>
-                <a:latin typeface="Calibri" pitchFamily="34" charset="0"/>
-                <a:ea typeface="Calibri" pitchFamily="34" charset="-122"/>
-                <a:cs typeface="Calibri" pitchFamily="34" charset="-120"/>
+                  <a:srgbClr val="0F0F0F"/>
+                </a:solidFill>
+                <a:latin typeface="Inter" pitchFamily="34" charset="0"/>
+                <a:ea typeface="Inter" pitchFamily="34" charset="-122"/>
+                <a:cs typeface="Inter" pitchFamily="34" charset="-120"/>
               </a:rPr>
               <a:t>Lieferung</a:t>
             </a:r>
@@ -6397,11 +6397,11 @@
             <a:r>
               <a:rPr lang="en-US" sz="1150" dirty="0">
                 <a:solidFill>
-                  <a:srgbClr val="6B7280"/>
-                </a:solidFill>
-                <a:latin typeface="Calibri" pitchFamily="34" charset="0"/>
-                <a:ea typeface="Calibri" pitchFamily="34" charset="-122"/>
-                <a:cs typeface="Calibri" pitchFamily="34" charset="-120"/>
+                  <a:srgbClr val="5C5C58"/>
+                </a:solidFill>
+                <a:latin typeface="Inter" pitchFamily="34" charset="0"/>
+                <a:ea typeface="Inter" pitchFamily="34" charset="-122"/>
+                <a:cs typeface="Inter" pitchFamily="34" charset="-120"/>
               </a:rPr>
               <a:t>Versand oder Abholung zum Wunschtermin</a:t>
             </a:r>
@@ -6439,11 +6439,11 @@
             <a:lvl1pPr>
               <a:defRPr sz="900">
                 <a:solidFill>
-                  <a:srgbClr val="6B7280"/>
-                </a:solidFill>
-                <a:latin typeface="Calibri"/>
-                <a:ea typeface="Calibri"/>
-                <a:cs typeface="Calibri"/>
+                  <a:srgbClr val="5C5C58"/>
+                </a:solidFill>
+                <a:latin typeface="Inter"/>
+                <a:ea typeface="Inter"/>
+                <a:cs typeface="Inter"/>
               </a:defRPr>
             </a:lvl1pPr>
           </a:lstStyle>
@@ -6493,7 +6493,7 @@
         <p:spPr>
           <a:xfrm>
             <a:off x="457200" y="320040"/>
-            <a:ext cx="6217920" cy="685800"/>
+            <a:ext cx="6858000" cy="685800"/>
           </a:xfrm>
           <a:prstGeom prst="rect">
             <a:avLst/>
@@ -6511,11 +6511,11 @@
             <a:r>
               <a:rPr lang="en-US" sz="2800" b="1" dirty="0">
                 <a:solidFill>
-                  <a:srgbClr val="111827"/>
-                </a:solidFill>
-                <a:latin typeface="Calibri" pitchFamily="34" charset="0"/>
-                <a:ea typeface="Calibri" pitchFamily="34" charset="-122"/>
-                <a:cs typeface="Calibri" pitchFamily="34" charset="-120"/>
+                  <a:srgbClr val="0F0F0F"/>
+                </a:solidFill>
+                <a:latin typeface="Inter" pitchFamily="34" charset="0"/>
+                <a:ea typeface="Inter" pitchFamily="34" charset="-122"/>
+                <a:cs typeface="Inter" pitchFamily="34" charset="-120"/>
               </a:rPr>
               <a:t>Angebotsübersicht</a:t>
             </a:r>
@@ -6566,23 +6566,23 @@
                           <a:solidFill>
                             <a:srgbClr val="FFFFFF"/>
                           </a:solidFill>
-                          <a:latin typeface="Calibri" pitchFamily="34" charset="0"/>
-                          <a:ea typeface="Calibri" pitchFamily="34" charset="-122"/>
-                          <a:cs typeface="Calibri" pitchFamily="34" charset="-120"/>
+                          <a:latin typeface="Inter" pitchFamily="34" charset="0"/>
+                          <a:ea typeface="Inter" pitchFamily="34" charset="-122"/>
+                          <a:cs typeface="Inter" pitchFamily="34" charset="-120"/>
                         </a:rPr>
                         <a:t>Pos.</a:t>
                       </a:r>
                       <a:endParaRPr lang="en-US" sz="1200" dirty="0">
-                        <a:latin typeface="Calibri" charset="0"/>
-                        <a:ea typeface="Calibri" charset="0"/>
-                        <a:cs typeface="Calibri" charset="0"/>
+                        <a:latin typeface="Inter" charset="0"/>
+                        <a:ea typeface="Inter" charset="0"/>
+                        <a:cs typeface="Inter" charset="0"/>
                       </a:endParaRPr>
                     </a:p>
                   </a:txBody>
                   <a:tcPr marL="91440" marR="91440" marT="36576" marB="36576" anchor="ctr">
                     <a:lnL w="9525" cap="flat" cmpd="sng" algn="ctr">
                       <a:solidFill>
-                        <a:srgbClr val="E5E7EB"/>
+                        <a:srgbClr val="D9D2C5"/>
                       </a:solidFill>
                       <a:prstDash val="solid"/>
                       <a:round/>
@@ -6591,7 +6591,7 @@
                     </a:lnL>
                     <a:lnR w="9525" cap="flat" cmpd="sng" algn="ctr">
                       <a:solidFill>
-                        <a:srgbClr val="E5E7EB"/>
+                        <a:srgbClr val="D9D2C5"/>
                       </a:solidFill>
                       <a:prstDash val="solid"/>
                       <a:round/>
@@ -6600,7 +6600,7 @@
                     </a:lnR>
                     <a:lnT w="9525" cap="flat" cmpd="sng" algn="ctr">
                       <a:solidFill>
-                        <a:srgbClr val="E5E7EB"/>
+                        <a:srgbClr val="D9D2C5"/>
                       </a:solidFill>
                       <a:prstDash val="solid"/>
                       <a:round/>
@@ -6609,7 +6609,7 @@
                     </a:lnT>
                     <a:lnB w="9525" cap="flat" cmpd="sng" algn="ctr">
                       <a:solidFill>
-                        <a:srgbClr val="E5E7EB"/>
+                        <a:srgbClr val="D9D2C5"/>
                       </a:solidFill>
                       <a:prstDash val="solid"/>
                       <a:round/>
@@ -6617,7 +6617,7 @@
                       <a:tailEnd type="none" w="med" len="med"/>
                     </a:lnB>
                     <a:solidFill>
-                      <a:srgbClr val="0B0F14"/>
+                      <a:srgbClr val="0F0F0F"/>
                     </a:solidFill>
                   </a:tcPr>
                 </a:tc>
@@ -6634,23 +6634,23 @@
                           <a:solidFill>
                             <a:srgbClr val="FFFFFF"/>
                           </a:solidFill>
-                          <a:latin typeface="Calibri" pitchFamily="34" charset="0"/>
-                          <a:ea typeface="Calibri" pitchFamily="34" charset="-122"/>
-                          <a:cs typeface="Calibri" pitchFamily="34" charset="-120"/>
+                          <a:latin typeface="Inter" pitchFamily="34" charset="0"/>
+                          <a:ea typeface="Inter" pitchFamily="34" charset="-122"/>
+                          <a:cs typeface="Inter" pitchFamily="34" charset="-120"/>
                         </a:rPr>
                         <a:t>Artikel</a:t>
                       </a:r>
                       <a:endParaRPr lang="en-US" sz="1200" dirty="0">
-                        <a:latin typeface="Calibri" charset="0"/>
-                        <a:ea typeface="Calibri" charset="0"/>
-                        <a:cs typeface="Calibri" charset="0"/>
+                        <a:latin typeface="Inter" charset="0"/>
+                        <a:ea typeface="Inter" charset="0"/>
+                        <a:cs typeface="Inter" charset="0"/>
                       </a:endParaRPr>
                     </a:p>
                   </a:txBody>
                   <a:tcPr marL="91440" marR="91440" marT="36576" marB="36576" anchor="ctr">
                     <a:lnL w="9525" cap="flat" cmpd="sng" algn="ctr">
                       <a:solidFill>
-                        <a:srgbClr val="E5E7EB"/>
+                        <a:srgbClr val="D9D2C5"/>
                       </a:solidFill>
                       <a:prstDash val="solid"/>
                       <a:round/>
@@ -6659,7 +6659,7 @@
                     </a:lnL>
                     <a:lnR w="9525" cap="flat" cmpd="sng" algn="ctr">
                       <a:solidFill>
-                        <a:srgbClr val="E5E7EB"/>
+                        <a:srgbClr val="D9D2C5"/>
                       </a:solidFill>
                       <a:prstDash val="solid"/>
                       <a:round/>
@@ -6668,7 +6668,7 @@
                     </a:lnR>
                     <a:lnT w="9525" cap="flat" cmpd="sng" algn="ctr">
                       <a:solidFill>
-                        <a:srgbClr val="E5E7EB"/>
+                        <a:srgbClr val="D9D2C5"/>
                       </a:solidFill>
                       <a:prstDash val="solid"/>
                       <a:round/>
@@ -6677,7 +6677,7 @@
                     </a:lnT>
                     <a:lnB w="9525" cap="flat" cmpd="sng" algn="ctr">
                       <a:solidFill>
-                        <a:srgbClr val="E5E7EB"/>
+                        <a:srgbClr val="D9D2C5"/>
                       </a:solidFill>
                       <a:prstDash val="solid"/>
                       <a:round/>
@@ -6685,7 +6685,7 @@
                       <a:tailEnd type="none" w="med" len="med"/>
                     </a:lnB>
                     <a:solidFill>
-                      <a:srgbClr val="0B0F14"/>
+                      <a:srgbClr val="0F0F0F"/>
                     </a:solidFill>
                   </a:tcPr>
                 </a:tc>
@@ -6702,23 +6702,23 @@
                           <a:solidFill>
                             <a:srgbClr val="FFFFFF"/>
                           </a:solidFill>
-                          <a:latin typeface="Calibri" pitchFamily="34" charset="0"/>
-                          <a:ea typeface="Calibri" pitchFamily="34" charset="-122"/>
-                          <a:cs typeface="Calibri" pitchFamily="34" charset="-120"/>
+                          <a:latin typeface="Inter" pitchFamily="34" charset="0"/>
+                          <a:ea typeface="Inter" pitchFamily="34" charset="-122"/>
+                          <a:cs typeface="Inter" pitchFamily="34" charset="-120"/>
                         </a:rPr>
                         <a:t>Menge</a:t>
                       </a:r>
                       <a:endParaRPr lang="en-US" sz="1200" dirty="0">
-                        <a:latin typeface="Calibri" charset="0"/>
-                        <a:ea typeface="Calibri" charset="0"/>
-                        <a:cs typeface="Calibri" charset="0"/>
+                        <a:latin typeface="Inter" charset="0"/>
+                        <a:ea typeface="Inter" charset="0"/>
+                        <a:cs typeface="Inter" charset="0"/>
                       </a:endParaRPr>
                     </a:p>
                   </a:txBody>
                   <a:tcPr marL="91440" marR="91440" marT="36576" marB="36576" anchor="ctr">
                     <a:lnL w="9525" cap="flat" cmpd="sng" algn="ctr">
                       <a:solidFill>
-                        <a:srgbClr val="E5E7EB"/>
+                        <a:srgbClr val="D9D2C5"/>
                       </a:solidFill>
                       <a:prstDash val="solid"/>
                       <a:round/>
@@ -6727,7 +6727,7 @@
                     </a:lnL>
                     <a:lnR w="9525" cap="flat" cmpd="sng" algn="ctr">
                       <a:solidFill>
-                        <a:srgbClr val="E5E7EB"/>
+                        <a:srgbClr val="D9D2C5"/>
                       </a:solidFill>
                       <a:prstDash val="solid"/>
                       <a:round/>
@@ -6736,7 +6736,7 @@
                     </a:lnR>
                     <a:lnT w="9525" cap="flat" cmpd="sng" algn="ctr">
                       <a:solidFill>
-                        <a:srgbClr val="E5E7EB"/>
+                        <a:srgbClr val="D9D2C5"/>
                       </a:solidFill>
                       <a:prstDash val="solid"/>
                       <a:round/>
@@ -6745,7 +6745,7 @@
                     </a:lnT>
                     <a:lnB w="9525" cap="flat" cmpd="sng" algn="ctr">
                       <a:solidFill>
-                        <a:srgbClr val="E5E7EB"/>
+                        <a:srgbClr val="D9D2C5"/>
                       </a:solidFill>
                       <a:prstDash val="solid"/>
                       <a:round/>
@@ -6753,7 +6753,7 @@
                       <a:tailEnd type="none" w="med" len="med"/>
                     </a:lnB>
                     <a:solidFill>
-                      <a:srgbClr val="0B0F14"/>
+                      <a:srgbClr val="0F0F0F"/>
                     </a:solidFill>
                   </a:tcPr>
                 </a:tc>
@@ -6770,23 +6770,23 @@
                           <a:solidFill>
                             <a:srgbClr val="FFFFFF"/>
                           </a:solidFill>
-                          <a:latin typeface="Calibri" pitchFamily="34" charset="0"/>
-                          <a:ea typeface="Calibri" pitchFamily="34" charset="-122"/>
-                          <a:cs typeface="Calibri" pitchFamily="34" charset="-120"/>
+                          <a:latin typeface="Inter" pitchFamily="34" charset="0"/>
+                          <a:ea typeface="Inter" pitchFamily="34" charset="-122"/>
+                          <a:cs typeface="Inter" pitchFamily="34" charset="-120"/>
                         </a:rPr>
                         <a:t>Einzelpreis</a:t>
                       </a:r>
                       <a:endParaRPr lang="en-US" sz="1200" dirty="0">
-                        <a:latin typeface="Calibri" charset="0"/>
-                        <a:ea typeface="Calibri" charset="0"/>
-                        <a:cs typeface="Calibri" charset="0"/>
+                        <a:latin typeface="Inter" charset="0"/>
+                        <a:ea typeface="Inter" charset="0"/>
+                        <a:cs typeface="Inter" charset="0"/>
                       </a:endParaRPr>
                     </a:p>
                   </a:txBody>
                   <a:tcPr marL="91440" marR="91440" marT="36576" marB="36576" anchor="ctr">
                     <a:lnL w="9525" cap="flat" cmpd="sng" algn="ctr">
                       <a:solidFill>
-                        <a:srgbClr val="E5E7EB"/>
+                        <a:srgbClr val="D9D2C5"/>
                       </a:solidFill>
                       <a:prstDash val="solid"/>
                       <a:round/>
@@ -6795,7 +6795,7 @@
                     </a:lnL>
                     <a:lnR w="9525" cap="flat" cmpd="sng" algn="ctr">
                       <a:solidFill>
-                        <a:srgbClr val="E5E7EB"/>
+                        <a:srgbClr val="D9D2C5"/>
                       </a:solidFill>
                       <a:prstDash val="solid"/>
                       <a:round/>
@@ -6804,7 +6804,7 @@
                     </a:lnR>
                     <a:lnT w="9525" cap="flat" cmpd="sng" algn="ctr">
                       <a:solidFill>
-                        <a:srgbClr val="E5E7EB"/>
+                        <a:srgbClr val="D9D2C5"/>
                       </a:solidFill>
                       <a:prstDash val="solid"/>
                       <a:round/>
@@ -6813,7 +6813,7 @@
                     </a:lnT>
                     <a:lnB w="9525" cap="flat" cmpd="sng" algn="ctr">
                       <a:solidFill>
-                        <a:srgbClr val="E5E7EB"/>
+                        <a:srgbClr val="D9D2C5"/>
                       </a:solidFill>
                       <a:prstDash val="solid"/>
                       <a:round/>
@@ -6821,7 +6821,7 @@
                       <a:tailEnd type="none" w="med" len="med"/>
                     </a:lnB>
                     <a:solidFill>
-                      <a:srgbClr val="0B0F14"/>
+                      <a:srgbClr val="0F0F0F"/>
                     </a:solidFill>
                   </a:tcPr>
                 </a:tc>
@@ -6838,23 +6838,23 @@
                           <a:solidFill>
                             <a:srgbClr val="FFFFFF"/>
                           </a:solidFill>
-                          <a:latin typeface="Calibri" pitchFamily="34" charset="0"/>
-                          <a:ea typeface="Calibri" pitchFamily="34" charset="-122"/>
-                          <a:cs typeface="Calibri" pitchFamily="34" charset="-120"/>
+                          <a:latin typeface="Inter" pitchFamily="34" charset="0"/>
+                          <a:ea typeface="Inter" pitchFamily="34" charset="-122"/>
+                          <a:cs typeface="Inter" pitchFamily="34" charset="-120"/>
                         </a:rPr>
                         <a:t>Gesamt</a:t>
                       </a:r>
                       <a:endParaRPr lang="en-US" sz="1200" dirty="0">
-                        <a:latin typeface="Calibri" charset="0"/>
-                        <a:ea typeface="Calibri" charset="0"/>
-                        <a:cs typeface="Calibri" charset="0"/>
+                        <a:latin typeface="Inter" charset="0"/>
+                        <a:ea typeface="Inter" charset="0"/>
+                        <a:cs typeface="Inter" charset="0"/>
                       </a:endParaRPr>
                     </a:p>
                   </a:txBody>
                   <a:tcPr marL="91440" marR="91440" marT="36576" marB="36576" anchor="ctr">
                     <a:lnL w="9525" cap="flat" cmpd="sng" algn="ctr">
                       <a:solidFill>
-                        <a:srgbClr val="E5E7EB"/>
+                        <a:srgbClr val="D9D2C5"/>
                       </a:solidFill>
                       <a:prstDash val="solid"/>
                       <a:round/>
@@ -6863,7 +6863,7 @@
                     </a:lnL>
                     <a:lnR w="9525" cap="flat" cmpd="sng" algn="ctr">
                       <a:solidFill>
-                        <a:srgbClr val="E5E7EB"/>
+                        <a:srgbClr val="D9D2C5"/>
                       </a:solidFill>
                       <a:prstDash val="solid"/>
                       <a:round/>
@@ -6872,7 +6872,7 @@
                     </a:lnR>
                     <a:lnT w="9525" cap="flat" cmpd="sng" algn="ctr">
                       <a:solidFill>
-                        <a:srgbClr val="E5E7EB"/>
+                        <a:srgbClr val="D9D2C5"/>
                       </a:solidFill>
                       <a:prstDash val="solid"/>
                       <a:round/>
@@ -6881,7 +6881,7 @@
                     </a:lnT>
                     <a:lnB w="9525" cap="flat" cmpd="sng" algn="ctr">
                       <a:solidFill>
-                        <a:srgbClr val="E5E7EB"/>
+                        <a:srgbClr val="D9D2C5"/>
                       </a:solidFill>
                       <a:prstDash val="solid"/>
                       <a:round/>
@@ -6889,7 +6889,7 @@
                       <a:tailEnd type="none" w="med" len="med"/>
                     </a:lnB>
                     <a:solidFill>
-                      <a:srgbClr val="0B0F14"/>
+                      <a:srgbClr val="0F0F0F"/>
                     </a:solidFill>
                   </a:tcPr>
                 </a:tc>
@@ -6906,25 +6906,25 @@
                       <a:r>
                         <a:rPr lang="en-US" sz="1200" dirty="0">
                           <a:solidFill>
-                            <a:srgbClr val="111827"/>
+                            <a:srgbClr val="0F0F0F"/>
                           </a:solidFill>
-                          <a:latin typeface="Calibri" pitchFamily="34" charset="0"/>
-                          <a:ea typeface="Calibri" pitchFamily="34" charset="-122"/>
-                          <a:cs typeface="Calibri" pitchFamily="34" charset="-120"/>
+                          <a:latin typeface="Inter" pitchFamily="34" charset="0"/>
+                          <a:ea typeface="Inter" pitchFamily="34" charset="-122"/>
+                          <a:cs typeface="Inter" pitchFamily="34" charset="-120"/>
                         </a:rPr>
                         <a:t>1</a:t>
                       </a:r>
                       <a:endParaRPr lang="en-US" sz="1200" dirty="0">
-                        <a:latin typeface="Calibri" charset="0"/>
-                        <a:ea typeface="Calibri" charset="0"/>
-                        <a:cs typeface="Calibri" charset="0"/>
+                        <a:latin typeface="Inter" charset="0"/>
+                        <a:ea typeface="Inter" charset="0"/>
+                        <a:cs typeface="Inter" charset="0"/>
                       </a:endParaRPr>
                     </a:p>
                   </a:txBody>
                   <a:tcPr marL="91440" marR="91440" marT="36576" marB="36576" anchor="ctr">
                     <a:lnL w="9525" cap="flat" cmpd="sng" algn="ctr">
                       <a:solidFill>
-                        <a:srgbClr val="E5E7EB"/>
+                        <a:srgbClr val="D9D2C5"/>
                       </a:solidFill>
                       <a:prstDash val="solid"/>
                       <a:round/>
@@ -6933,7 +6933,7 @@
                     </a:lnL>
                     <a:lnR w="9525" cap="flat" cmpd="sng" algn="ctr">
                       <a:solidFill>
-                        <a:srgbClr val="E5E7EB"/>
+                        <a:srgbClr val="D9D2C5"/>
                       </a:solidFill>
                       <a:prstDash val="solid"/>
                       <a:round/>
@@ -6942,7 +6942,7 @@
                     </a:lnR>
                     <a:lnT w="9525" cap="flat" cmpd="sng" algn="ctr">
                       <a:solidFill>
-                        <a:srgbClr val="E5E7EB"/>
+                        <a:srgbClr val="D9D2C5"/>
                       </a:solidFill>
                       <a:prstDash val="solid"/>
                       <a:round/>
@@ -6951,7 +6951,7 @@
                     </a:lnT>
                     <a:lnB w="9525" cap="flat" cmpd="sng" algn="ctr">
                       <a:solidFill>
-                        <a:srgbClr val="E5E7EB"/>
+                        <a:srgbClr val="D9D2C5"/>
                       </a:solidFill>
                       <a:prstDash val="solid"/>
                       <a:round/>
@@ -6974,25 +6974,25 @@
                       <a:r>
                         <a:rPr lang="en-US" sz="1200" dirty="0">
                           <a:solidFill>
-                            <a:srgbClr val="111827"/>
+                            <a:srgbClr val="0F0F0F"/>
                           </a:solidFill>
-                          <a:latin typeface="Calibri" pitchFamily="34" charset="0"/>
-                          <a:ea typeface="Calibri" pitchFamily="34" charset="-122"/>
-                          <a:cs typeface="Calibri" pitchFamily="34" charset="-120"/>
+                          <a:latin typeface="Inter" pitchFamily="34" charset="0"/>
+                          <a:ea typeface="Inter" pitchFamily="34" charset="-122"/>
+                          <a:cs typeface="Inter" pitchFamily="34" charset="-120"/>
                         </a:rPr>
                         <a:t>T-Shirt Bio-Baumwolle, Brustdruck 1-farbig</a:t>
                       </a:r>
                       <a:endParaRPr lang="en-US" sz="1200" dirty="0">
-                        <a:latin typeface="Calibri" charset="0"/>
-                        <a:ea typeface="Calibri" charset="0"/>
-                        <a:cs typeface="Calibri" charset="0"/>
+                        <a:latin typeface="Inter" charset="0"/>
+                        <a:ea typeface="Inter" charset="0"/>
+                        <a:cs typeface="Inter" charset="0"/>
                       </a:endParaRPr>
                     </a:p>
                   </a:txBody>
                   <a:tcPr marL="91440" marR="91440" marT="36576" marB="36576" anchor="ctr">
                     <a:lnL w="9525" cap="flat" cmpd="sng" algn="ctr">
                       <a:solidFill>
-                        <a:srgbClr val="E5E7EB"/>
+                        <a:srgbClr val="D9D2C5"/>
                       </a:solidFill>
                       <a:prstDash val="solid"/>
                       <a:round/>
@@ -7001,7 +7001,7 @@
                     </a:lnL>
                     <a:lnR w="9525" cap="flat" cmpd="sng" algn="ctr">
                       <a:solidFill>
-                        <a:srgbClr val="E5E7EB"/>
+                        <a:srgbClr val="D9D2C5"/>
                       </a:solidFill>
                       <a:prstDash val="solid"/>
                       <a:round/>
@@ -7010,7 +7010,7 @@
                     </a:lnR>
                     <a:lnT w="9525" cap="flat" cmpd="sng" algn="ctr">
                       <a:solidFill>
-                        <a:srgbClr val="E5E7EB"/>
+                        <a:srgbClr val="D9D2C5"/>
                       </a:solidFill>
                       <a:prstDash val="solid"/>
                       <a:round/>
@@ -7019,7 +7019,7 @@
                     </a:lnT>
                     <a:lnB w="9525" cap="flat" cmpd="sng" algn="ctr">
                       <a:solidFill>
-                        <a:srgbClr val="E5E7EB"/>
+                        <a:srgbClr val="D9D2C5"/>
                       </a:solidFill>
                       <a:prstDash val="solid"/>
                       <a:round/>
@@ -7042,25 +7042,25 @@
                       <a:r>
                         <a:rPr lang="en-US" sz="1200" dirty="0">
                           <a:solidFill>
-                            <a:srgbClr val="111827"/>
+                            <a:srgbClr val="0F0F0F"/>
                           </a:solidFill>
-                          <a:latin typeface="Calibri" pitchFamily="34" charset="0"/>
-                          <a:ea typeface="Calibri" pitchFamily="34" charset="-122"/>
-                          <a:cs typeface="Calibri" pitchFamily="34" charset="-120"/>
+                          <a:latin typeface="Inter" pitchFamily="34" charset="0"/>
+                          <a:ea typeface="Inter" pitchFamily="34" charset="-122"/>
+                          <a:cs typeface="Inter" pitchFamily="34" charset="-120"/>
                         </a:rPr>
                         <a:t>50</a:t>
                       </a:r>
                       <a:endParaRPr lang="en-US" sz="1200" dirty="0">
-                        <a:latin typeface="Calibri" charset="0"/>
-                        <a:ea typeface="Calibri" charset="0"/>
-                        <a:cs typeface="Calibri" charset="0"/>
+                        <a:latin typeface="Inter" charset="0"/>
+                        <a:ea typeface="Inter" charset="0"/>
+                        <a:cs typeface="Inter" charset="0"/>
                       </a:endParaRPr>
                     </a:p>
                   </a:txBody>
                   <a:tcPr marL="91440" marR="91440" marT="36576" marB="36576" anchor="ctr">
                     <a:lnL w="9525" cap="flat" cmpd="sng" algn="ctr">
                       <a:solidFill>
-                        <a:srgbClr val="E5E7EB"/>
+                        <a:srgbClr val="D9D2C5"/>
                       </a:solidFill>
                       <a:prstDash val="solid"/>
                       <a:round/>
@@ -7069,7 +7069,7 @@
                     </a:lnL>
                     <a:lnR w="9525" cap="flat" cmpd="sng" algn="ctr">
                       <a:solidFill>
-                        <a:srgbClr val="E5E7EB"/>
+                        <a:srgbClr val="D9D2C5"/>
                       </a:solidFill>
                       <a:prstDash val="solid"/>
                       <a:round/>
@@ -7078,7 +7078,7 @@
                     </a:lnR>
                     <a:lnT w="9525" cap="flat" cmpd="sng" algn="ctr">
                       <a:solidFill>
-                        <a:srgbClr val="E5E7EB"/>
+                        <a:srgbClr val="D9D2C5"/>
                       </a:solidFill>
                       <a:prstDash val="solid"/>
                       <a:round/>
@@ -7087,7 +7087,7 @@
                     </a:lnT>
                     <a:lnB w="9525" cap="flat" cmpd="sng" algn="ctr">
                       <a:solidFill>
-                        <a:srgbClr val="E5E7EB"/>
+                        <a:srgbClr val="D9D2C5"/>
                       </a:solidFill>
                       <a:prstDash val="solid"/>
                       <a:round/>
@@ -7110,25 +7110,25 @@
                       <a:r>
                         <a:rPr lang="en-US" sz="1200" dirty="0">
                           <a:solidFill>
-                            <a:srgbClr val="111827"/>
+                            <a:srgbClr val="0F0F0F"/>
                           </a:solidFill>
-                          <a:latin typeface="Calibri" pitchFamily="34" charset="0"/>
-                          <a:ea typeface="Calibri" pitchFamily="34" charset="-122"/>
-                          <a:cs typeface="Calibri" pitchFamily="34" charset="-120"/>
+                          <a:latin typeface="Inter" pitchFamily="34" charset="0"/>
+                          <a:ea typeface="Inter" pitchFamily="34" charset="-122"/>
+                          <a:cs typeface="Inter" pitchFamily="34" charset="-120"/>
                         </a:rPr>
                         <a:t>12,90 €</a:t>
                       </a:r>
                       <a:endParaRPr lang="en-US" sz="1200" dirty="0">
-                        <a:latin typeface="Calibri" charset="0"/>
-                        <a:ea typeface="Calibri" charset="0"/>
-                        <a:cs typeface="Calibri" charset="0"/>
+                        <a:latin typeface="Inter" charset="0"/>
+                        <a:ea typeface="Inter" charset="0"/>
+                        <a:cs typeface="Inter" charset="0"/>
                       </a:endParaRPr>
                     </a:p>
                   </a:txBody>
                   <a:tcPr marL="91440" marR="91440" marT="36576" marB="36576" anchor="ctr">
                     <a:lnL w="9525" cap="flat" cmpd="sng" algn="ctr">
                       <a:solidFill>
-                        <a:srgbClr val="E5E7EB"/>
+                        <a:srgbClr val="D9D2C5"/>
                       </a:solidFill>
                       <a:prstDash val="solid"/>
                       <a:round/>
@@ -7137,7 +7137,7 @@
                     </a:lnL>
                     <a:lnR w="9525" cap="flat" cmpd="sng" algn="ctr">
                       <a:solidFill>
-                        <a:srgbClr val="E5E7EB"/>
+                        <a:srgbClr val="D9D2C5"/>
                       </a:solidFill>
                       <a:prstDash val="solid"/>
                       <a:round/>
@@ -7146,7 +7146,7 @@
                     </a:lnR>
                     <a:lnT w="9525" cap="flat" cmpd="sng" algn="ctr">
                       <a:solidFill>
-                        <a:srgbClr val="E5E7EB"/>
+                        <a:srgbClr val="D9D2C5"/>
                       </a:solidFill>
                       <a:prstDash val="solid"/>
                       <a:round/>
@@ -7155,7 +7155,7 @@
                     </a:lnT>
                     <a:lnB w="9525" cap="flat" cmpd="sng" algn="ctr">
                       <a:solidFill>
-                        <a:srgbClr val="E5E7EB"/>
+                        <a:srgbClr val="D9D2C5"/>
                       </a:solidFill>
                       <a:prstDash val="solid"/>
                       <a:round/>
@@ -7178,25 +7178,25 @@
                       <a:r>
                         <a:rPr lang="en-US" sz="1200" dirty="0">
                           <a:solidFill>
-                            <a:srgbClr val="111827"/>
+                            <a:srgbClr val="0F0F0F"/>
                           </a:solidFill>
-                          <a:latin typeface="Calibri" pitchFamily="34" charset="0"/>
-                          <a:ea typeface="Calibri" pitchFamily="34" charset="-122"/>
-                          <a:cs typeface="Calibri" pitchFamily="34" charset="-120"/>
+                          <a:latin typeface="Inter" pitchFamily="34" charset="0"/>
+                          <a:ea typeface="Inter" pitchFamily="34" charset="-122"/>
+                          <a:cs typeface="Inter" pitchFamily="34" charset="-120"/>
                         </a:rPr>
                         <a:t>645,00 €</a:t>
                       </a:r>
                       <a:endParaRPr lang="en-US" sz="1200" dirty="0">
-                        <a:latin typeface="Calibri" charset="0"/>
-                        <a:ea typeface="Calibri" charset="0"/>
-                        <a:cs typeface="Calibri" charset="0"/>
+                        <a:latin typeface="Inter" charset="0"/>
+                        <a:ea typeface="Inter" charset="0"/>
+                        <a:cs typeface="Inter" charset="0"/>
                       </a:endParaRPr>
                     </a:p>
                   </a:txBody>
                   <a:tcPr marL="91440" marR="91440" marT="36576" marB="36576" anchor="ctr">
                     <a:lnL w="9525" cap="flat" cmpd="sng" algn="ctr">
                       <a:solidFill>
-                        <a:srgbClr val="E5E7EB"/>
+                        <a:srgbClr val="D9D2C5"/>
                       </a:solidFill>
                       <a:prstDash val="solid"/>
                       <a:round/>
@@ -7205,7 +7205,7 @@
                     </a:lnL>
                     <a:lnR w="9525" cap="flat" cmpd="sng" algn="ctr">
                       <a:solidFill>
-                        <a:srgbClr val="E5E7EB"/>
+                        <a:srgbClr val="D9D2C5"/>
                       </a:solidFill>
                       <a:prstDash val="solid"/>
                       <a:round/>
@@ -7214,7 +7214,7 @@
                     </a:lnR>
                     <a:lnT w="9525" cap="flat" cmpd="sng" algn="ctr">
                       <a:solidFill>
-                        <a:srgbClr val="E5E7EB"/>
+                        <a:srgbClr val="D9D2C5"/>
                       </a:solidFill>
                       <a:prstDash val="solid"/>
                       <a:round/>
@@ -7223,7 +7223,7 @@
                     </a:lnT>
                     <a:lnB w="9525" cap="flat" cmpd="sng" algn="ctr">
                       <a:solidFill>
-                        <a:srgbClr val="E5E7EB"/>
+                        <a:srgbClr val="D9D2C5"/>
                       </a:solidFill>
                       <a:prstDash val="solid"/>
                       <a:round/>
@@ -7248,25 +7248,25 @@
                       <a:r>
                         <a:rPr lang="en-US" sz="1200" dirty="0">
                           <a:solidFill>
-                            <a:srgbClr val="111827"/>
+                            <a:srgbClr val="0F0F0F"/>
                           </a:solidFill>
-                          <a:latin typeface="Calibri" pitchFamily="34" charset="0"/>
-                          <a:ea typeface="Calibri" pitchFamily="34" charset="-122"/>
-                          <a:cs typeface="Calibri" pitchFamily="34" charset="-120"/>
+                          <a:latin typeface="Inter" pitchFamily="34" charset="0"/>
+                          <a:ea typeface="Inter" pitchFamily="34" charset="-122"/>
+                          <a:cs typeface="Inter" pitchFamily="34" charset="-120"/>
                         </a:rPr>
                         <a:t>2</a:t>
                       </a:r>
                       <a:endParaRPr lang="en-US" sz="1200" dirty="0">
-                        <a:latin typeface="Calibri" charset="0"/>
-                        <a:ea typeface="Calibri" charset="0"/>
-                        <a:cs typeface="Calibri" charset="0"/>
+                        <a:latin typeface="Inter" charset="0"/>
+                        <a:ea typeface="Inter" charset="0"/>
+                        <a:cs typeface="Inter" charset="0"/>
                       </a:endParaRPr>
                     </a:p>
                   </a:txBody>
                   <a:tcPr marL="91440" marR="91440" marT="36576" marB="36576" anchor="ctr">
                     <a:lnL w="9525" cap="flat" cmpd="sng" algn="ctr">
                       <a:solidFill>
-                        <a:srgbClr val="E5E7EB"/>
+                        <a:srgbClr val="D9D2C5"/>
                       </a:solidFill>
                       <a:prstDash val="solid"/>
                       <a:round/>
@@ -7275,7 +7275,7 @@
                     </a:lnL>
                     <a:lnR w="9525" cap="flat" cmpd="sng" algn="ctr">
                       <a:solidFill>
-                        <a:srgbClr val="E5E7EB"/>
+                        <a:srgbClr val="D9D2C5"/>
                       </a:solidFill>
                       <a:prstDash val="solid"/>
                       <a:round/>
@@ -7284,7 +7284,7 @@
                     </a:lnR>
                     <a:lnT w="9525" cap="flat" cmpd="sng" algn="ctr">
                       <a:solidFill>
-                        <a:srgbClr val="E5E7EB"/>
+                        <a:srgbClr val="D9D2C5"/>
                       </a:solidFill>
                       <a:prstDash val="solid"/>
                       <a:round/>
@@ -7293,7 +7293,7 @@
                     </a:lnT>
                     <a:lnB w="9525" cap="flat" cmpd="sng" algn="ctr">
                       <a:solidFill>
-                        <a:srgbClr val="E5E7EB"/>
+                        <a:srgbClr val="D9D2C5"/>
                       </a:solidFill>
                       <a:prstDash val="solid"/>
                       <a:round/>
@@ -7316,25 +7316,25 @@
                       <a:r>
                         <a:rPr lang="en-US" sz="1200" dirty="0">
                           <a:solidFill>
-                            <a:srgbClr val="111827"/>
+                            <a:srgbClr val="0F0F0F"/>
                           </a:solidFill>
-                          <a:latin typeface="Calibri" pitchFamily="34" charset="0"/>
-                          <a:ea typeface="Calibri" pitchFamily="34" charset="-122"/>
-                          <a:cs typeface="Calibri" pitchFamily="34" charset="-120"/>
+                          <a:latin typeface="Inter" pitchFamily="34" charset="0"/>
+                          <a:ea typeface="Inter" pitchFamily="34" charset="-122"/>
+                          <a:cs typeface="Inter" pitchFamily="34" charset="-120"/>
                         </a:rPr>
                         <a:t>Hoodie, Rückendruck 2-farbig</a:t>
                       </a:r>
                       <a:endParaRPr lang="en-US" sz="1200" dirty="0">
-                        <a:latin typeface="Calibri" charset="0"/>
-                        <a:ea typeface="Calibri" charset="0"/>
-                        <a:cs typeface="Calibri" charset="0"/>
+                        <a:latin typeface="Inter" charset="0"/>
+                        <a:ea typeface="Inter" charset="0"/>
+                        <a:cs typeface="Inter" charset="0"/>
                       </a:endParaRPr>
                     </a:p>
                   </a:txBody>
                   <a:tcPr marL="91440" marR="91440" marT="36576" marB="36576" anchor="ctr">
                     <a:lnL w="9525" cap="flat" cmpd="sng" algn="ctr">
                       <a:solidFill>
-                        <a:srgbClr val="E5E7EB"/>
+                        <a:srgbClr val="D9D2C5"/>
                       </a:solidFill>
                       <a:prstDash val="solid"/>
                       <a:round/>
@@ -7343,7 +7343,7 @@
                     </a:lnL>
                     <a:lnR w="9525" cap="flat" cmpd="sng" algn="ctr">
                       <a:solidFill>
-                        <a:srgbClr val="E5E7EB"/>
+                        <a:srgbClr val="D9D2C5"/>
                       </a:solidFill>
                       <a:prstDash val="solid"/>
                       <a:round/>
@@ -7352,7 +7352,7 @@
                     </a:lnR>
                     <a:lnT w="9525" cap="flat" cmpd="sng" algn="ctr">
                       <a:solidFill>
-                        <a:srgbClr val="E5E7EB"/>
+                        <a:srgbClr val="D9D2C5"/>
                       </a:solidFill>
                       <a:prstDash val="solid"/>
                       <a:round/>
@@ -7361,7 +7361,7 @@
                     </a:lnT>
                     <a:lnB w="9525" cap="flat" cmpd="sng" algn="ctr">
                       <a:solidFill>
-                        <a:srgbClr val="E5E7EB"/>
+                        <a:srgbClr val="D9D2C5"/>
                       </a:solidFill>
                       <a:prstDash val="solid"/>
                       <a:round/>
@@ -7384,25 +7384,25 @@
                       <a:r>
                         <a:rPr lang="en-US" sz="1200" dirty="0">
                           <a:solidFill>
-                            <a:srgbClr val="111827"/>
+                            <a:srgbClr val="0F0F0F"/>
                           </a:solidFill>
-                          <a:latin typeface="Calibri" pitchFamily="34" charset="0"/>
-                          <a:ea typeface="Calibri" pitchFamily="34" charset="-122"/>
-                          <a:cs typeface="Calibri" pitchFamily="34" charset="-120"/>
+                          <a:latin typeface="Inter" pitchFamily="34" charset="0"/>
+                          <a:ea typeface="Inter" pitchFamily="34" charset="-122"/>
+                          <a:cs typeface="Inter" pitchFamily="34" charset="-120"/>
                         </a:rPr>
                         <a:t>25</a:t>
                       </a:r>
                       <a:endParaRPr lang="en-US" sz="1200" dirty="0">
-                        <a:latin typeface="Calibri" charset="0"/>
-                        <a:ea typeface="Calibri" charset="0"/>
-                        <a:cs typeface="Calibri" charset="0"/>
+                        <a:latin typeface="Inter" charset="0"/>
+                        <a:ea typeface="Inter" charset="0"/>
+                        <a:cs typeface="Inter" charset="0"/>
                       </a:endParaRPr>
                     </a:p>
                   </a:txBody>
                   <a:tcPr marL="91440" marR="91440" marT="36576" marB="36576" anchor="ctr">
                     <a:lnL w="9525" cap="flat" cmpd="sng" algn="ctr">
                       <a:solidFill>
-                        <a:srgbClr val="E5E7EB"/>
+                        <a:srgbClr val="D9D2C5"/>
                       </a:solidFill>
                       <a:prstDash val="solid"/>
                       <a:round/>
@@ -7411,7 +7411,7 @@
                     </a:lnL>
                     <a:lnR w="9525" cap="flat" cmpd="sng" algn="ctr">
                       <a:solidFill>
-                        <a:srgbClr val="E5E7EB"/>
+                        <a:srgbClr val="D9D2C5"/>
                       </a:solidFill>
                       <a:prstDash val="solid"/>
                       <a:round/>
@@ -7420,7 +7420,7 @@
                     </a:lnR>
                     <a:lnT w="9525" cap="flat" cmpd="sng" algn="ctr">
                       <a:solidFill>
-                        <a:srgbClr val="E5E7EB"/>
+                        <a:srgbClr val="D9D2C5"/>
                       </a:solidFill>
                       <a:prstDash val="solid"/>
                       <a:round/>
@@ -7429,7 +7429,7 @@
                     </a:lnT>
                     <a:lnB w="9525" cap="flat" cmpd="sng" algn="ctr">
                       <a:solidFill>
-                        <a:srgbClr val="E5E7EB"/>
+                        <a:srgbClr val="D9D2C5"/>
                       </a:solidFill>
                       <a:prstDash val="solid"/>
                       <a:round/>
@@ -7452,25 +7452,25 @@
                       <a:r>
                         <a:rPr lang="en-US" sz="1200" dirty="0">
                           <a:solidFill>
-                            <a:srgbClr val="111827"/>
+                            <a:srgbClr val="0F0F0F"/>
                           </a:solidFill>
-                          <a:latin typeface="Calibri" pitchFamily="34" charset="0"/>
-                          <a:ea typeface="Calibri" pitchFamily="34" charset="-122"/>
-                          <a:cs typeface="Calibri" pitchFamily="34" charset="-120"/>
+                          <a:latin typeface="Inter" pitchFamily="34" charset="0"/>
+                          <a:ea typeface="Inter" pitchFamily="34" charset="-122"/>
+                          <a:cs typeface="Inter" pitchFamily="34" charset="-120"/>
                         </a:rPr>
                         <a:t>34,50 €</a:t>
                       </a:r>
                       <a:endParaRPr lang="en-US" sz="1200" dirty="0">
-                        <a:latin typeface="Calibri" charset="0"/>
-                        <a:ea typeface="Calibri" charset="0"/>
-                        <a:cs typeface="Calibri" charset="0"/>
+                        <a:latin typeface="Inter" charset="0"/>
+                        <a:ea typeface="Inter" charset="0"/>
+                        <a:cs typeface="Inter" charset="0"/>
                       </a:endParaRPr>
                     </a:p>
                   </a:txBody>
                   <a:tcPr marL="91440" marR="91440" marT="36576" marB="36576" anchor="ctr">
                     <a:lnL w="9525" cap="flat" cmpd="sng" algn="ctr">
                       <a:solidFill>
-                        <a:srgbClr val="E5E7EB"/>
+                        <a:srgbClr val="D9D2C5"/>
                       </a:solidFill>
                       <a:prstDash val="solid"/>
                       <a:round/>
@@ -7479,7 +7479,7 @@
                     </a:lnL>
                     <a:lnR w="9525" cap="flat" cmpd="sng" algn="ctr">
                       <a:solidFill>
-                        <a:srgbClr val="E5E7EB"/>
+                        <a:srgbClr val="D9D2C5"/>
                       </a:solidFill>
                       <a:prstDash val="solid"/>
                       <a:round/>
@@ -7488,7 +7488,7 @@
                     </a:lnR>
                     <a:lnT w="9525" cap="flat" cmpd="sng" algn="ctr">
                       <a:solidFill>
-                        <a:srgbClr val="E5E7EB"/>
+                        <a:srgbClr val="D9D2C5"/>
                       </a:solidFill>
                       <a:prstDash val="solid"/>
                       <a:round/>
@@ -7497,7 +7497,7 @@
                     </a:lnT>
                     <a:lnB w="9525" cap="flat" cmpd="sng" algn="ctr">
                       <a:solidFill>
-                        <a:srgbClr val="E5E7EB"/>
+                        <a:srgbClr val="D9D2C5"/>
                       </a:solidFill>
                       <a:prstDash val="solid"/>
                       <a:round/>
@@ -7520,25 +7520,25 @@
                       <a:r>
                         <a:rPr lang="en-US" sz="1200" dirty="0">
                           <a:solidFill>
-                            <a:srgbClr val="111827"/>
+                            <a:srgbClr val="0F0F0F"/>
                           </a:solidFill>
-                          <a:latin typeface="Calibri" pitchFamily="34" charset="0"/>
-                          <a:ea typeface="Calibri" pitchFamily="34" charset="-122"/>
-                          <a:cs typeface="Calibri" pitchFamily="34" charset="-120"/>
+                          <a:latin typeface="Inter" pitchFamily="34" charset="0"/>
+                          <a:ea typeface="Inter" pitchFamily="34" charset="-122"/>
+                          <a:cs typeface="Inter" pitchFamily="34" charset="-120"/>
                         </a:rPr>
                         <a:t>862,50 €</a:t>
                       </a:r>
                       <a:endParaRPr lang="en-US" sz="1200" dirty="0">
-                        <a:latin typeface="Calibri" charset="0"/>
-                        <a:ea typeface="Calibri" charset="0"/>
-                        <a:cs typeface="Calibri" charset="0"/>
+                        <a:latin typeface="Inter" charset="0"/>
+                        <a:ea typeface="Inter" charset="0"/>
+                        <a:cs typeface="Inter" charset="0"/>
                       </a:endParaRPr>
                     </a:p>
                   </a:txBody>
                   <a:tcPr marL="91440" marR="91440" marT="36576" marB="36576" anchor="ctr">
                     <a:lnL w="9525" cap="flat" cmpd="sng" algn="ctr">
                       <a:solidFill>
-                        <a:srgbClr val="E5E7EB"/>
+                        <a:srgbClr val="D9D2C5"/>
                       </a:solidFill>
                       <a:prstDash val="solid"/>
                       <a:round/>
@@ -7547,7 +7547,7 @@
                     </a:lnL>
                     <a:lnR w="9525" cap="flat" cmpd="sng" algn="ctr">
                       <a:solidFill>
-                        <a:srgbClr val="E5E7EB"/>
+                        <a:srgbClr val="D9D2C5"/>
                       </a:solidFill>
                       <a:prstDash val="solid"/>
                       <a:round/>
@@ -7556,7 +7556,7 @@
                     </a:lnR>
                     <a:lnT w="9525" cap="flat" cmpd="sng" algn="ctr">
                       <a:solidFill>
-                        <a:srgbClr val="E5E7EB"/>
+                        <a:srgbClr val="D9D2C5"/>
                       </a:solidFill>
                       <a:prstDash val="solid"/>
                       <a:round/>
@@ -7565,7 +7565,7 @@
                     </a:lnT>
                     <a:lnB w="9525" cap="flat" cmpd="sng" algn="ctr">
                       <a:solidFill>
-                        <a:srgbClr val="E5E7EB"/>
+                        <a:srgbClr val="D9D2C5"/>
                       </a:solidFill>
                       <a:prstDash val="solid"/>
                       <a:round/>
@@ -7590,25 +7590,25 @@
                       <a:r>
                         <a:rPr lang="en-US" sz="1200" dirty="0">
                           <a:solidFill>
-                            <a:srgbClr val="111827"/>
+                            <a:srgbClr val="0F0F0F"/>
                           </a:solidFill>
-                          <a:latin typeface="Calibri" pitchFamily="34" charset="0"/>
-                          <a:ea typeface="Calibri" pitchFamily="34" charset="-122"/>
-                          <a:cs typeface="Calibri" pitchFamily="34" charset="-120"/>
+                          <a:latin typeface="Inter" pitchFamily="34" charset="0"/>
+                          <a:ea typeface="Inter" pitchFamily="34" charset="-122"/>
+                          <a:cs typeface="Inter" pitchFamily="34" charset="-120"/>
                         </a:rPr>
                         <a:t>3</a:t>
                       </a:r>
                       <a:endParaRPr lang="en-US" sz="1200" dirty="0">
-                        <a:latin typeface="Calibri" charset="0"/>
-                        <a:ea typeface="Calibri" charset="0"/>
-                        <a:cs typeface="Calibri" charset="0"/>
+                        <a:latin typeface="Inter" charset="0"/>
+                        <a:ea typeface="Inter" charset="0"/>
+                        <a:cs typeface="Inter" charset="0"/>
                       </a:endParaRPr>
                     </a:p>
                   </a:txBody>
                   <a:tcPr marL="91440" marR="91440" marT="36576" marB="36576" anchor="ctr">
                     <a:lnL w="9525" cap="flat" cmpd="sng" algn="ctr">
                       <a:solidFill>
-                        <a:srgbClr val="E5E7EB"/>
+                        <a:srgbClr val="D9D2C5"/>
                       </a:solidFill>
                       <a:prstDash val="solid"/>
                       <a:round/>
@@ -7617,7 +7617,7 @@
                     </a:lnL>
                     <a:lnR w="9525" cap="flat" cmpd="sng" algn="ctr">
                       <a:solidFill>
-                        <a:srgbClr val="E5E7EB"/>
+                        <a:srgbClr val="D9D2C5"/>
                       </a:solidFill>
                       <a:prstDash val="solid"/>
                       <a:round/>
@@ -7626,7 +7626,7 @@
                     </a:lnR>
                     <a:lnT w="9525" cap="flat" cmpd="sng" algn="ctr">
                       <a:solidFill>
-                        <a:srgbClr val="E5E7EB"/>
+                        <a:srgbClr val="D9D2C5"/>
                       </a:solidFill>
                       <a:prstDash val="solid"/>
                       <a:round/>
@@ -7635,7 +7635,7 @@
                     </a:lnT>
                     <a:lnB w="9525" cap="flat" cmpd="sng" algn="ctr">
                       <a:solidFill>
-                        <a:srgbClr val="E5E7EB"/>
+                        <a:srgbClr val="D9D2C5"/>
                       </a:solidFill>
                       <a:prstDash val="solid"/>
                       <a:round/>
@@ -7658,25 +7658,25 @@
                       <a:r>
                         <a:rPr lang="en-US" sz="1200" dirty="0">
                           <a:solidFill>
-                            <a:srgbClr val="111827"/>
+                            <a:srgbClr val="0F0F0F"/>
                           </a:solidFill>
-                          <a:latin typeface="Calibri" pitchFamily="34" charset="0"/>
-                          <a:ea typeface="Calibri" pitchFamily="34" charset="-122"/>
-                          <a:cs typeface="Calibri" pitchFamily="34" charset="-120"/>
+                          <a:latin typeface="Inter" pitchFamily="34" charset="0"/>
+                          <a:ea typeface="Inter" pitchFamily="34" charset="-122"/>
+                          <a:cs typeface="Inter" pitchFamily="34" charset="-120"/>
                         </a:rPr>
                         <a:t>Polo-Shirt, Logo-Stickerei</a:t>
                       </a:r>
                       <a:endParaRPr lang="en-US" sz="1200" dirty="0">
-                        <a:latin typeface="Calibri" charset="0"/>
-                        <a:ea typeface="Calibri" charset="0"/>
-                        <a:cs typeface="Calibri" charset="0"/>
+                        <a:latin typeface="Inter" charset="0"/>
+                        <a:ea typeface="Inter" charset="0"/>
+                        <a:cs typeface="Inter" charset="0"/>
                       </a:endParaRPr>
                     </a:p>
                   </a:txBody>
                   <a:tcPr marL="91440" marR="91440" marT="36576" marB="36576" anchor="ctr">
                     <a:lnL w="9525" cap="flat" cmpd="sng" algn="ctr">
                       <a:solidFill>
-                        <a:srgbClr val="E5E7EB"/>
+                        <a:srgbClr val="D9D2C5"/>
                       </a:solidFill>
                       <a:prstDash val="solid"/>
                       <a:round/>
@@ -7685,7 +7685,7 @@
                     </a:lnL>
                     <a:lnR w="9525" cap="flat" cmpd="sng" algn="ctr">
                       <a:solidFill>
-                        <a:srgbClr val="E5E7EB"/>
+                        <a:srgbClr val="D9D2C5"/>
                       </a:solidFill>
                       <a:prstDash val="solid"/>
                       <a:round/>
@@ -7694,7 +7694,7 @@
                     </a:lnR>
                     <a:lnT w="9525" cap="flat" cmpd="sng" algn="ctr">
                       <a:solidFill>
-                        <a:srgbClr val="E5E7EB"/>
+                        <a:srgbClr val="D9D2C5"/>
                       </a:solidFill>
                       <a:prstDash val="solid"/>
                       <a:round/>
@@ -7703,7 +7703,7 @@
                     </a:lnT>
                     <a:lnB w="9525" cap="flat" cmpd="sng" algn="ctr">
                       <a:solidFill>
-                        <a:srgbClr val="E5E7EB"/>
+                        <a:srgbClr val="D9D2C5"/>
                       </a:solidFill>
                       <a:prstDash val="solid"/>
                       <a:round/>
@@ -7726,25 +7726,25 @@
                       <a:r>
                         <a:rPr lang="en-US" sz="1200" dirty="0">
                           <a:solidFill>
-                            <a:srgbClr val="111827"/>
+                            <a:srgbClr val="0F0F0F"/>
                           </a:solidFill>
-                          <a:latin typeface="Calibri" pitchFamily="34" charset="0"/>
-                          <a:ea typeface="Calibri" pitchFamily="34" charset="-122"/>
-                          <a:cs typeface="Calibri" pitchFamily="34" charset="-120"/>
+                          <a:latin typeface="Inter" pitchFamily="34" charset="0"/>
+                          <a:ea typeface="Inter" pitchFamily="34" charset="-122"/>
+                          <a:cs typeface="Inter" pitchFamily="34" charset="-120"/>
                         </a:rPr>
                         <a:t>20</a:t>
                       </a:r>
                       <a:endParaRPr lang="en-US" sz="1200" dirty="0">
-                        <a:latin typeface="Calibri" charset="0"/>
-                        <a:ea typeface="Calibri" charset="0"/>
-                        <a:cs typeface="Calibri" charset="0"/>
+                        <a:latin typeface="Inter" charset="0"/>
+                        <a:ea typeface="Inter" charset="0"/>
+                        <a:cs typeface="Inter" charset="0"/>
                       </a:endParaRPr>
                     </a:p>
                   </a:txBody>
                   <a:tcPr marL="91440" marR="91440" marT="36576" marB="36576" anchor="ctr">
                     <a:lnL w="9525" cap="flat" cmpd="sng" algn="ctr">
                       <a:solidFill>
-                        <a:srgbClr val="E5E7EB"/>
+                        <a:srgbClr val="D9D2C5"/>
                       </a:solidFill>
                       <a:prstDash val="solid"/>
                       <a:round/>
@@ -7753,7 +7753,7 @@
                     </a:lnL>
                     <a:lnR w="9525" cap="flat" cmpd="sng" algn="ctr">
                       <a:solidFill>
-                        <a:srgbClr val="E5E7EB"/>
+                        <a:srgbClr val="D9D2C5"/>
                       </a:solidFill>
                       <a:prstDash val="solid"/>
                       <a:round/>
@@ -7762,7 +7762,7 @@
                     </a:lnR>
                     <a:lnT w="9525" cap="flat" cmpd="sng" algn="ctr">
                       <a:solidFill>
-                        <a:srgbClr val="E5E7EB"/>
+                        <a:srgbClr val="D9D2C5"/>
                       </a:solidFill>
                       <a:prstDash val="solid"/>
                       <a:round/>
@@ -7771,7 +7771,7 @@
                     </a:lnT>
                     <a:lnB w="9525" cap="flat" cmpd="sng" algn="ctr">
                       <a:solidFill>
-                        <a:srgbClr val="E5E7EB"/>
+                        <a:srgbClr val="D9D2C5"/>
                       </a:solidFill>
                       <a:prstDash val="solid"/>
                       <a:round/>
@@ -7794,25 +7794,25 @@
                       <a:r>
                         <a:rPr lang="en-US" sz="1200" dirty="0">
                           <a:solidFill>
-                            <a:srgbClr val="111827"/>
+                            <a:srgbClr val="0F0F0F"/>
                           </a:solidFill>
-                          <a:latin typeface="Calibri" pitchFamily="34" charset="0"/>
-                          <a:ea typeface="Calibri" pitchFamily="34" charset="-122"/>
-                          <a:cs typeface="Calibri" pitchFamily="34" charset="-120"/>
+                          <a:latin typeface="Inter" pitchFamily="34" charset="0"/>
+                          <a:ea typeface="Inter" pitchFamily="34" charset="-122"/>
+                          <a:cs typeface="Inter" pitchFamily="34" charset="-120"/>
                         </a:rPr>
                         <a:t>26,00 €</a:t>
                       </a:r>
                       <a:endParaRPr lang="en-US" sz="1200" dirty="0">
-                        <a:latin typeface="Calibri" charset="0"/>
-                        <a:ea typeface="Calibri" charset="0"/>
-                        <a:cs typeface="Calibri" charset="0"/>
+                        <a:latin typeface="Inter" charset="0"/>
+                        <a:ea typeface="Inter" charset="0"/>
+                        <a:cs typeface="Inter" charset="0"/>
                       </a:endParaRPr>
                     </a:p>
                   </a:txBody>
                   <a:tcPr marL="91440" marR="91440" marT="36576" marB="36576" anchor="ctr">
                     <a:lnL w="9525" cap="flat" cmpd="sng" algn="ctr">
                       <a:solidFill>
-                        <a:srgbClr val="E5E7EB"/>
+                        <a:srgbClr val="D9D2C5"/>
                       </a:solidFill>
                       <a:prstDash val="solid"/>
                       <a:round/>
@@ -7821,7 +7821,7 @@
                     </a:lnL>
                     <a:lnR w="9525" cap="flat" cmpd="sng" algn="ctr">
                       <a:solidFill>
-                        <a:srgbClr val="E5E7EB"/>
+                        <a:srgbClr val="D9D2C5"/>
                       </a:solidFill>
                       <a:prstDash val="solid"/>
                       <a:round/>
@@ -7830,7 +7830,7 @@
                     </a:lnR>
                     <a:lnT w="9525" cap="flat" cmpd="sng" algn="ctr">
                       <a:solidFill>
-                        <a:srgbClr val="E5E7EB"/>
+                        <a:srgbClr val="D9D2C5"/>
                       </a:solidFill>
                       <a:prstDash val="solid"/>
                       <a:round/>
@@ -7839,7 +7839,7 @@
                     </a:lnT>
                     <a:lnB w="9525" cap="flat" cmpd="sng" algn="ctr">
                       <a:solidFill>
-                        <a:srgbClr val="E5E7EB"/>
+                        <a:srgbClr val="D9D2C5"/>
                       </a:solidFill>
                       <a:prstDash val="solid"/>
                       <a:round/>
@@ -7862,25 +7862,25 @@
                       <a:r>
                         <a:rPr lang="en-US" sz="1200" dirty="0">
                           <a:solidFill>
-                            <a:srgbClr val="111827"/>
+                            <a:srgbClr val="0F0F0F"/>
                           </a:solidFill>
-                          <a:latin typeface="Calibri" pitchFamily="34" charset="0"/>
-                          <a:ea typeface="Calibri" pitchFamily="34" charset="-122"/>
-                          <a:cs typeface="Calibri" pitchFamily="34" charset="-120"/>
+                          <a:latin typeface="Inter" pitchFamily="34" charset="0"/>
+                          <a:ea typeface="Inter" pitchFamily="34" charset="-122"/>
+                          <a:cs typeface="Inter" pitchFamily="34" charset="-120"/>
                         </a:rPr>
                         <a:t>520,00 €</a:t>
                       </a:r>
                       <a:endParaRPr lang="en-US" sz="1200" dirty="0">
-                        <a:latin typeface="Calibri" charset="0"/>
-                        <a:ea typeface="Calibri" charset="0"/>
-                        <a:cs typeface="Calibri" charset="0"/>
+                        <a:latin typeface="Inter" charset="0"/>
+                        <a:ea typeface="Inter" charset="0"/>
+                        <a:cs typeface="Inter" charset="0"/>
                       </a:endParaRPr>
                     </a:p>
                   </a:txBody>
                   <a:tcPr marL="91440" marR="91440" marT="36576" marB="36576" anchor="ctr">
                     <a:lnL w="9525" cap="flat" cmpd="sng" algn="ctr">
                       <a:solidFill>
-                        <a:srgbClr val="E5E7EB"/>
+                        <a:srgbClr val="D9D2C5"/>
                       </a:solidFill>
                       <a:prstDash val="solid"/>
                       <a:round/>
@@ -7889,7 +7889,7 @@
                     </a:lnL>
                     <a:lnR w="9525" cap="flat" cmpd="sng" algn="ctr">
                       <a:solidFill>
-                        <a:srgbClr val="E5E7EB"/>
+                        <a:srgbClr val="D9D2C5"/>
                       </a:solidFill>
                       <a:prstDash val="solid"/>
                       <a:round/>
@@ -7898,7 +7898,7 @@
                     </a:lnR>
                     <a:lnT w="9525" cap="flat" cmpd="sng" algn="ctr">
                       <a:solidFill>
-                        <a:srgbClr val="E5E7EB"/>
+                        <a:srgbClr val="D9D2C5"/>
                       </a:solidFill>
                       <a:prstDash val="solid"/>
                       <a:round/>
@@ -7907,7 +7907,7 @@
                     </a:lnT>
                     <a:lnB w="9525" cap="flat" cmpd="sng" algn="ctr">
                       <a:solidFill>
-                        <a:srgbClr val="E5E7EB"/>
+                        <a:srgbClr val="D9D2C5"/>
                       </a:solidFill>
                       <a:prstDash val="solid"/>
                       <a:round/>
@@ -7932,25 +7932,25 @@
                       <a:r>
                         <a:rPr lang="en-US" sz="1200" dirty="0">
                           <a:solidFill>
-                            <a:srgbClr val="111827"/>
+                            <a:srgbClr val="0F0F0F"/>
                           </a:solidFill>
-                          <a:latin typeface="Calibri" pitchFamily="34" charset="0"/>
-                          <a:ea typeface="Calibri" pitchFamily="34" charset="-122"/>
-                          <a:cs typeface="Calibri" pitchFamily="34" charset="-120"/>
+                          <a:latin typeface="Inter" pitchFamily="34" charset="0"/>
+                          <a:ea typeface="Inter" pitchFamily="34" charset="-122"/>
+                          <a:cs typeface="Inter" pitchFamily="34" charset="-120"/>
                         </a:rPr>
                         <a:t>4</a:t>
                       </a:r>
                       <a:endParaRPr lang="en-US" sz="1200" dirty="0">
-                        <a:latin typeface="Calibri" charset="0"/>
-                        <a:ea typeface="Calibri" charset="0"/>
-                        <a:cs typeface="Calibri" charset="0"/>
+                        <a:latin typeface="Inter" charset="0"/>
+                        <a:ea typeface="Inter" charset="0"/>
+                        <a:cs typeface="Inter" charset="0"/>
                       </a:endParaRPr>
                     </a:p>
                   </a:txBody>
                   <a:tcPr marL="91440" marR="91440" marT="36576" marB="36576" anchor="ctr">
                     <a:lnL w="9525" cap="flat" cmpd="sng" algn="ctr">
                       <a:solidFill>
-                        <a:srgbClr val="E5E7EB"/>
+                        <a:srgbClr val="D9D2C5"/>
                       </a:solidFill>
                       <a:prstDash val="solid"/>
                       <a:round/>
@@ -7959,7 +7959,7 @@
                     </a:lnL>
                     <a:lnR w="9525" cap="flat" cmpd="sng" algn="ctr">
                       <a:solidFill>
-                        <a:srgbClr val="E5E7EB"/>
+                        <a:srgbClr val="D9D2C5"/>
                       </a:solidFill>
                       <a:prstDash val="solid"/>
                       <a:round/>
@@ -7968,7 +7968,7 @@
                     </a:lnR>
                     <a:lnT w="9525" cap="flat" cmpd="sng" algn="ctr">
                       <a:solidFill>
-                        <a:srgbClr val="E5E7EB"/>
+                        <a:srgbClr val="D9D2C5"/>
                       </a:solidFill>
                       <a:prstDash val="solid"/>
                       <a:round/>
@@ -7977,7 +7977,7 @@
                     </a:lnT>
                     <a:lnB w="9525" cap="flat" cmpd="sng" algn="ctr">
                       <a:solidFill>
-                        <a:srgbClr val="E5E7EB"/>
+                        <a:srgbClr val="D9D2C5"/>
                       </a:solidFill>
                       <a:prstDash val="solid"/>
                       <a:round/>
@@ -8000,25 +8000,25 @@
                       <a:r>
                         <a:rPr lang="en-US" sz="1200" dirty="0">
                           <a:solidFill>
-                            <a:srgbClr val="111827"/>
+                            <a:srgbClr val="0F0F0F"/>
                           </a:solidFill>
-                          <a:latin typeface="Calibri" pitchFamily="34" charset="0"/>
-                          <a:ea typeface="Calibri" pitchFamily="34" charset="-122"/>
-                          <a:cs typeface="Calibri" pitchFamily="34" charset="-120"/>
+                          <a:latin typeface="Inter" pitchFamily="34" charset="0"/>
+                          <a:ea typeface="Inter" pitchFamily="34" charset="-122"/>
+                          <a:cs typeface="Inter" pitchFamily="34" charset="-120"/>
                         </a:rPr>
                         <a:t>Einrichtungskosten Siebdruck</a:t>
                       </a:r>
                       <a:endParaRPr lang="en-US" sz="1200" dirty="0">
-                        <a:latin typeface="Calibri" charset="0"/>
-                        <a:ea typeface="Calibri" charset="0"/>
-                        <a:cs typeface="Calibri" charset="0"/>
+                        <a:latin typeface="Inter" charset="0"/>
+                        <a:ea typeface="Inter" charset="0"/>
+                        <a:cs typeface="Inter" charset="0"/>
                       </a:endParaRPr>
                     </a:p>
                   </a:txBody>
                   <a:tcPr marL="91440" marR="91440" marT="36576" marB="36576" anchor="ctr">
                     <a:lnL w="9525" cap="flat" cmpd="sng" algn="ctr">
                       <a:solidFill>
-                        <a:srgbClr val="E5E7EB"/>
+                        <a:srgbClr val="D9D2C5"/>
                       </a:solidFill>
                       <a:prstDash val="solid"/>
                       <a:round/>
@@ -8027,7 +8027,7 @@
                     </a:lnL>
                     <a:lnR w="9525" cap="flat" cmpd="sng" algn="ctr">
                       <a:solidFill>
-                        <a:srgbClr val="E5E7EB"/>
+                        <a:srgbClr val="D9D2C5"/>
                       </a:solidFill>
                       <a:prstDash val="solid"/>
                       <a:round/>
@@ -8036,7 +8036,7 @@
                     </a:lnR>
                     <a:lnT w="9525" cap="flat" cmpd="sng" algn="ctr">
                       <a:solidFill>
-                        <a:srgbClr val="E5E7EB"/>
+                        <a:srgbClr val="D9D2C5"/>
                       </a:solidFill>
                       <a:prstDash val="solid"/>
                       <a:round/>
@@ -8045,7 +8045,7 @@
                     </a:lnT>
                     <a:lnB w="9525" cap="flat" cmpd="sng" algn="ctr">
                       <a:solidFill>
-                        <a:srgbClr val="E5E7EB"/>
+                        <a:srgbClr val="D9D2C5"/>
                       </a:solidFill>
                       <a:prstDash val="solid"/>
                       <a:round/>
@@ -8068,25 +8068,25 @@
                       <a:r>
                         <a:rPr lang="en-US" sz="1200" dirty="0">
                           <a:solidFill>
-                            <a:srgbClr val="111827"/>
+                            <a:srgbClr val="0F0F0F"/>
                           </a:solidFill>
-                          <a:latin typeface="Calibri" pitchFamily="34" charset="0"/>
-                          <a:ea typeface="Calibri" pitchFamily="34" charset="-122"/>
-                          <a:cs typeface="Calibri" pitchFamily="34" charset="-120"/>
+                          <a:latin typeface="Inter" pitchFamily="34" charset="0"/>
+                          <a:ea typeface="Inter" pitchFamily="34" charset="-122"/>
+                          <a:cs typeface="Inter" pitchFamily="34" charset="-120"/>
                         </a:rPr>
                         <a:t>1</a:t>
                       </a:r>
                       <a:endParaRPr lang="en-US" sz="1200" dirty="0">
-                        <a:latin typeface="Calibri" charset="0"/>
-                        <a:ea typeface="Calibri" charset="0"/>
-                        <a:cs typeface="Calibri" charset="0"/>
+                        <a:latin typeface="Inter" charset="0"/>
+                        <a:ea typeface="Inter" charset="0"/>
+                        <a:cs typeface="Inter" charset="0"/>
                       </a:endParaRPr>
                     </a:p>
                   </a:txBody>
                   <a:tcPr marL="91440" marR="91440" marT="36576" marB="36576" anchor="ctr">
                     <a:lnL w="9525" cap="flat" cmpd="sng" algn="ctr">
                       <a:solidFill>
-                        <a:srgbClr val="E5E7EB"/>
+                        <a:srgbClr val="D9D2C5"/>
                       </a:solidFill>
                       <a:prstDash val="solid"/>
                       <a:round/>
@@ -8095,7 +8095,7 @@
                     </a:lnL>
                     <a:lnR w="9525" cap="flat" cmpd="sng" algn="ctr">
                       <a:solidFill>
-                        <a:srgbClr val="E5E7EB"/>
+                        <a:srgbClr val="D9D2C5"/>
                       </a:solidFill>
                       <a:prstDash val="solid"/>
                       <a:round/>
@@ -8104,7 +8104,7 @@
                     </a:lnR>
                     <a:lnT w="9525" cap="flat" cmpd="sng" algn="ctr">
                       <a:solidFill>
-                        <a:srgbClr val="E5E7EB"/>
+                        <a:srgbClr val="D9D2C5"/>
                       </a:solidFill>
                       <a:prstDash val="solid"/>
                       <a:round/>
@@ -8113,7 +8113,7 @@
                     </a:lnT>
                     <a:lnB w="9525" cap="flat" cmpd="sng" algn="ctr">
                       <a:solidFill>
-                        <a:srgbClr val="E5E7EB"/>
+                        <a:srgbClr val="D9D2C5"/>
                       </a:solidFill>
                       <a:prstDash val="solid"/>
                       <a:round/>
@@ -8136,25 +8136,25 @@
                       <a:r>
                         <a:rPr lang="en-US" sz="1200" dirty="0">
                           <a:solidFill>
-                            <a:srgbClr val="111827"/>
+                            <a:srgbClr val="0F0F0F"/>
                           </a:solidFill>
-                          <a:latin typeface="Calibri" pitchFamily="34" charset="0"/>
-                          <a:ea typeface="Calibri" pitchFamily="34" charset="-122"/>
-                          <a:cs typeface="Calibri" pitchFamily="34" charset="-120"/>
+                          <a:latin typeface="Inter" pitchFamily="34" charset="0"/>
+                          <a:ea typeface="Inter" pitchFamily="34" charset="-122"/>
+                          <a:cs typeface="Inter" pitchFamily="34" charset="-120"/>
                         </a:rPr>
                         <a:t>45,00 €</a:t>
                       </a:r>
                       <a:endParaRPr lang="en-US" sz="1200" dirty="0">
-                        <a:latin typeface="Calibri" charset="0"/>
-                        <a:ea typeface="Calibri" charset="0"/>
-                        <a:cs typeface="Calibri" charset="0"/>
+                        <a:latin typeface="Inter" charset="0"/>
+                        <a:ea typeface="Inter" charset="0"/>
+                        <a:cs typeface="Inter" charset="0"/>
                       </a:endParaRPr>
                     </a:p>
                   </a:txBody>
                   <a:tcPr marL="91440" marR="91440" marT="36576" marB="36576" anchor="ctr">
                     <a:lnL w="9525" cap="flat" cmpd="sng" algn="ctr">
                       <a:solidFill>
-                        <a:srgbClr val="E5E7EB"/>
+                        <a:srgbClr val="D9D2C5"/>
                       </a:solidFill>
                       <a:prstDash val="solid"/>
                       <a:round/>
@@ -8163,7 +8163,7 @@
                     </a:lnL>
                     <a:lnR w="9525" cap="flat" cmpd="sng" algn="ctr">
                       <a:solidFill>
-                        <a:srgbClr val="E5E7EB"/>
+                        <a:srgbClr val="D9D2C5"/>
                       </a:solidFill>
                       <a:prstDash val="solid"/>
                       <a:round/>
@@ -8172,7 +8172,7 @@
                     </a:lnR>
                     <a:lnT w="9525" cap="flat" cmpd="sng" algn="ctr">
                       <a:solidFill>
-                        <a:srgbClr val="E5E7EB"/>
+                        <a:srgbClr val="D9D2C5"/>
                       </a:solidFill>
                       <a:prstDash val="solid"/>
                       <a:round/>
@@ -8181,7 +8181,7 @@
                     </a:lnT>
                     <a:lnB w="9525" cap="flat" cmpd="sng" algn="ctr">
                       <a:solidFill>
-                        <a:srgbClr val="E5E7EB"/>
+                        <a:srgbClr val="D9D2C5"/>
                       </a:solidFill>
                       <a:prstDash val="solid"/>
                       <a:round/>
@@ -8204,25 +8204,25 @@
                       <a:r>
                         <a:rPr lang="en-US" sz="1200" dirty="0">
                           <a:solidFill>
-                            <a:srgbClr val="111827"/>
+                            <a:srgbClr val="0F0F0F"/>
                           </a:solidFill>
-                          <a:latin typeface="Calibri" pitchFamily="34" charset="0"/>
-                          <a:ea typeface="Calibri" pitchFamily="34" charset="-122"/>
-                          <a:cs typeface="Calibri" pitchFamily="34" charset="-120"/>
+                          <a:latin typeface="Inter" pitchFamily="34" charset="0"/>
+                          <a:ea typeface="Inter" pitchFamily="34" charset="-122"/>
+                          <a:cs typeface="Inter" pitchFamily="34" charset="-120"/>
                         </a:rPr>
                         <a:t>45,00 €</a:t>
                       </a:r>
                       <a:endParaRPr lang="en-US" sz="1200" dirty="0">
-                        <a:latin typeface="Calibri" charset="0"/>
-                        <a:ea typeface="Calibri" charset="0"/>
-                        <a:cs typeface="Calibri" charset="0"/>
+                        <a:latin typeface="Inter" charset="0"/>
+                        <a:ea typeface="Inter" charset="0"/>
+                        <a:cs typeface="Inter" charset="0"/>
                       </a:endParaRPr>
                     </a:p>
                   </a:txBody>
                   <a:tcPr marL="91440" marR="91440" marT="36576" marB="36576" anchor="ctr">
                     <a:lnL w="9525" cap="flat" cmpd="sng" algn="ctr">
                       <a:solidFill>
-                        <a:srgbClr val="E5E7EB"/>
+                        <a:srgbClr val="D9D2C5"/>
                       </a:solidFill>
                       <a:prstDash val="solid"/>
                       <a:round/>
@@ -8231,7 +8231,7 @@
                     </a:lnL>
                     <a:lnR w="9525" cap="flat" cmpd="sng" algn="ctr">
                       <a:solidFill>
-                        <a:srgbClr val="E5E7EB"/>
+                        <a:srgbClr val="D9D2C5"/>
                       </a:solidFill>
                       <a:prstDash val="solid"/>
                       <a:round/>
@@ -8240,7 +8240,7 @@
                     </a:lnR>
                     <a:lnT w="9525" cap="flat" cmpd="sng" algn="ctr">
                       <a:solidFill>
-                        <a:srgbClr val="E5E7EB"/>
+                        <a:srgbClr val="D9D2C5"/>
                       </a:solidFill>
                       <a:prstDash val="solid"/>
                       <a:round/>
@@ -8249,7 +8249,7 @@
                     </a:lnT>
                     <a:lnB w="9525" cap="flat" cmpd="sng" algn="ctr">
                       <a:solidFill>
-                        <a:srgbClr val="E5E7EB"/>
+                        <a:srgbClr val="D9D2C5"/>
                       </a:solidFill>
                       <a:prstDash val="solid"/>
                       <a:round/>
@@ -8272,16 +8272,16 @@
                         <a:buNone/>
                       </a:pPr>
                       <a:endParaRPr lang="en-US" sz="1200" dirty="0">
-                        <a:latin typeface="Calibri" charset="0"/>
-                        <a:ea typeface="Calibri" charset="0"/>
-                        <a:cs typeface="Calibri" charset="0"/>
+                        <a:latin typeface="Inter" charset="0"/>
+                        <a:ea typeface="Inter" charset="0"/>
+                        <a:cs typeface="Inter" charset="0"/>
                       </a:endParaRPr>
                     </a:p>
                   </a:txBody>
                   <a:tcPr marL="91440" marR="91440" marT="36576" marB="36576" anchor="ctr">
                     <a:lnL w="9525" cap="flat" cmpd="sng" algn="ctr">
                       <a:solidFill>
-                        <a:srgbClr val="E5E7EB"/>
+                        <a:srgbClr val="D9D2C5"/>
                       </a:solidFill>
                       <a:prstDash val="solid"/>
                       <a:round/>
@@ -8290,7 +8290,7 @@
                     </a:lnL>
                     <a:lnR w="9525" cap="flat" cmpd="sng" algn="ctr">
                       <a:solidFill>
-                        <a:srgbClr val="E5E7EB"/>
+                        <a:srgbClr val="D9D2C5"/>
                       </a:solidFill>
                       <a:prstDash val="solid"/>
                       <a:round/>
@@ -8299,7 +8299,7 @@
                     </a:lnR>
                     <a:lnT w="9525" cap="flat" cmpd="sng" algn="ctr">
                       <a:solidFill>
-                        <a:srgbClr val="E5E7EB"/>
+                        <a:srgbClr val="D9D2C5"/>
                       </a:solidFill>
                       <a:prstDash val="solid"/>
                       <a:round/>
@@ -8308,7 +8308,7 @@
                     </a:lnT>
                     <a:lnB w="9525" cap="flat" cmpd="sng" algn="ctr">
                       <a:solidFill>
-                        <a:srgbClr val="E5E7EB"/>
+                        <a:srgbClr val="D9D2C5"/>
                       </a:solidFill>
                       <a:prstDash val="solid"/>
                       <a:round/>
@@ -8331,25 +8331,25 @@
                       <a:r>
                         <a:rPr lang="en-US" sz="1200" b="1" dirty="0">
                           <a:solidFill>
-                            <a:srgbClr val="111827"/>
+                            <a:srgbClr val="0F0F0F"/>
                           </a:solidFill>
-                          <a:latin typeface="Calibri" pitchFamily="34" charset="0"/>
-                          <a:ea typeface="Calibri" pitchFamily="34" charset="-122"/>
-                          <a:cs typeface="Calibri" pitchFamily="34" charset="-120"/>
+                          <a:latin typeface="Inter" pitchFamily="34" charset="0"/>
+                          <a:ea typeface="Inter" pitchFamily="34" charset="-122"/>
+                          <a:cs typeface="Inter" pitchFamily="34" charset="-120"/>
                         </a:rPr>
                         <a:t>Netto gesamt</a:t>
                       </a:r>
                       <a:endParaRPr lang="en-US" sz="1200" dirty="0">
-                        <a:latin typeface="Calibri" charset="0"/>
-                        <a:ea typeface="Calibri" charset="0"/>
-                        <a:cs typeface="Calibri" charset="0"/>
+                        <a:latin typeface="Inter" charset="0"/>
+                        <a:ea typeface="Inter" charset="0"/>
+                        <a:cs typeface="Inter" charset="0"/>
                       </a:endParaRPr>
                     </a:p>
                   </a:txBody>
                   <a:tcPr marL="91440" marR="91440" marT="36576" marB="36576" anchor="ctr">
                     <a:lnL w="9525" cap="flat" cmpd="sng" algn="ctr">
                       <a:solidFill>
-                        <a:srgbClr val="E5E7EB"/>
+                        <a:srgbClr val="D9D2C5"/>
                       </a:solidFill>
                       <a:prstDash val="solid"/>
                       <a:round/>
@@ -8358,7 +8358,7 @@
                     </a:lnL>
                     <a:lnR w="9525" cap="flat" cmpd="sng" algn="ctr">
                       <a:solidFill>
-                        <a:srgbClr val="E5E7EB"/>
+                        <a:srgbClr val="D9D2C5"/>
                       </a:solidFill>
                       <a:prstDash val="solid"/>
                       <a:round/>
@@ -8367,7 +8367,7 @@
                     </a:lnR>
                     <a:lnT w="9525" cap="flat" cmpd="sng" algn="ctr">
                       <a:solidFill>
-                        <a:srgbClr val="E5E7EB"/>
+                        <a:srgbClr val="D9D2C5"/>
                       </a:solidFill>
                       <a:prstDash val="solid"/>
                       <a:round/>
@@ -8376,7 +8376,7 @@
                     </a:lnT>
                     <a:lnB w="9525" cap="flat" cmpd="sng" algn="ctr">
                       <a:solidFill>
-                        <a:srgbClr val="E5E7EB"/>
+                        <a:srgbClr val="D9D2C5"/>
                       </a:solidFill>
                       <a:prstDash val="solid"/>
                       <a:round/>
@@ -8397,16 +8397,16 @@
                         <a:buNone/>
                       </a:pPr>
                       <a:endParaRPr lang="en-US" sz="1200" dirty="0">
-                        <a:latin typeface="Calibri" charset="0"/>
-                        <a:ea typeface="Calibri" charset="0"/>
-                        <a:cs typeface="Calibri" charset="0"/>
+                        <a:latin typeface="Inter" charset="0"/>
+                        <a:ea typeface="Inter" charset="0"/>
+                        <a:cs typeface="Inter" charset="0"/>
                       </a:endParaRPr>
                     </a:p>
                   </a:txBody>
                   <a:tcPr marL="91440" marR="91440" marT="36576" marB="36576" anchor="ctr">
                     <a:lnL w="9525" cap="flat" cmpd="sng" algn="ctr">
                       <a:solidFill>
-                        <a:srgbClr val="E5E7EB"/>
+                        <a:srgbClr val="D9D2C5"/>
                       </a:solidFill>
                       <a:prstDash val="solid"/>
                       <a:round/>
@@ -8415,7 +8415,7 @@
                     </a:lnL>
                     <a:lnR w="9525" cap="flat" cmpd="sng" algn="ctr">
                       <a:solidFill>
-                        <a:srgbClr val="E5E7EB"/>
+                        <a:srgbClr val="D9D2C5"/>
                       </a:solidFill>
                       <a:prstDash val="solid"/>
                       <a:round/>
@@ -8424,7 +8424,7 @@
                     </a:lnR>
                     <a:lnT w="9525" cap="flat" cmpd="sng" algn="ctr">
                       <a:solidFill>
-                        <a:srgbClr val="E5E7EB"/>
+                        <a:srgbClr val="D9D2C5"/>
                       </a:solidFill>
                       <a:prstDash val="solid"/>
                       <a:round/>
@@ -8433,7 +8433,7 @@
                     </a:lnT>
                     <a:lnB w="9525" cap="flat" cmpd="sng" algn="ctr">
                       <a:solidFill>
-                        <a:srgbClr val="E5E7EB"/>
+                        <a:srgbClr val="D9D2C5"/>
                       </a:solidFill>
                       <a:prstDash val="solid"/>
                       <a:round/>
@@ -8454,16 +8454,16 @@
                         <a:buNone/>
                       </a:pPr>
                       <a:endParaRPr lang="en-US" sz="1200" dirty="0">
-                        <a:latin typeface="Calibri" charset="0"/>
-                        <a:ea typeface="Calibri" charset="0"/>
-                        <a:cs typeface="Calibri" charset="0"/>
+                        <a:latin typeface="Inter" charset="0"/>
+                        <a:ea typeface="Inter" charset="0"/>
+                        <a:cs typeface="Inter" charset="0"/>
                       </a:endParaRPr>
                     </a:p>
                   </a:txBody>
                   <a:tcPr marL="91440" marR="91440" marT="36576" marB="36576" anchor="ctr">
                     <a:lnL w="9525" cap="flat" cmpd="sng" algn="ctr">
                       <a:solidFill>
-                        <a:srgbClr val="E5E7EB"/>
+                        <a:srgbClr val="D9D2C5"/>
                       </a:solidFill>
                       <a:prstDash val="solid"/>
                       <a:round/>
@@ -8472,7 +8472,7 @@
                     </a:lnL>
                     <a:lnR w="9525" cap="flat" cmpd="sng" algn="ctr">
                       <a:solidFill>
-                        <a:srgbClr val="E5E7EB"/>
+                        <a:srgbClr val="D9D2C5"/>
                       </a:solidFill>
                       <a:prstDash val="solid"/>
                       <a:round/>
@@ -8481,7 +8481,7 @@
                     </a:lnR>
                     <a:lnT w="9525" cap="flat" cmpd="sng" algn="ctr">
                       <a:solidFill>
-                        <a:srgbClr val="E5E7EB"/>
+                        <a:srgbClr val="D9D2C5"/>
                       </a:solidFill>
                       <a:prstDash val="solid"/>
                       <a:round/>
@@ -8490,7 +8490,7 @@
                     </a:lnT>
                     <a:lnB w="9525" cap="flat" cmpd="sng" algn="ctr">
                       <a:solidFill>
-                        <a:srgbClr val="E5E7EB"/>
+                        <a:srgbClr val="D9D2C5"/>
                       </a:solidFill>
                       <a:prstDash val="solid"/>
                       <a:round/>
@@ -8513,25 +8513,25 @@
                       <a:r>
                         <a:rPr lang="en-US" sz="1200" b="1" dirty="0">
                           <a:solidFill>
-                            <a:srgbClr val="15803D"/>
+                            <a:srgbClr val="677E5B"/>
                           </a:solidFill>
-                          <a:latin typeface="Calibri" pitchFamily="34" charset="0"/>
-                          <a:ea typeface="Calibri" pitchFamily="34" charset="-122"/>
-                          <a:cs typeface="Calibri" pitchFamily="34" charset="-120"/>
+                          <a:latin typeface="Inter" pitchFamily="34" charset="0"/>
+                          <a:ea typeface="Inter" pitchFamily="34" charset="-122"/>
+                          <a:cs typeface="Inter" pitchFamily="34" charset="-120"/>
                         </a:rPr>
                         <a:t>2.072,50 €</a:t>
                       </a:r>
                       <a:endParaRPr lang="en-US" sz="1200" dirty="0">
-                        <a:latin typeface="Calibri" charset="0"/>
-                        <a:ea typeface="Calibri" charset="0"/>
-                        <a:cs typeface="Calibri" charset="0"/>
+                        <a:latin typeface="Inter" charset="0"/>
+                        <a:ea typeface="Inter" charset="0"/>
+                        <a:cs typeface="Inter" charset="0"/>
                       </a:endParaRPr>
                     </a:p>
                   </a:txBody>
                   <a:tcPr marL="91440" marR="91440" marT="36576" marB="36576" anchor="ctr">
                     <a:lnL w="9525" cap="flat" cmpd="sng" algn="ctr">
                       <a:solidFill>
-                        <a:srgbClr val="E5E7EB"/>
+                        <a:srgbClr val="D9D2C5"/>
                       </a:solidFill>
                       <a:prstDash val="solid"/>
                       <a:round/>
@@ -8540,7 +8540,7 @@
                     </a:lnL>
                     <a:lnR w="9525" cap="flat" cmpd="sng" algn="ctr">
                       <a:solidFill>
-                        <a:srgbClr val="E5E7EB"/>
+                        <a:srgbClr val="D9D2C5"/>
                       </a:solidFill>
                       <a:prstDash val="solid"/>
                       <a:round/>
@@ -8549,7 +8549,7 @@
                     </a:lnR>
                     <a:lnT w="9525" cap="flat" cmpd="sng" algn="ctr">
                       <a:solidFill>
-                        <a:srgbClr val="E5E7EB"/>
+                        <a:srgbClr val="D9D2C5"/>
                       </a:solidFill>
                       <a:prstDash val="solid"/>
                       <a:round/>
@@ -8558,7 +8558,7 @@
                     </a:lnT>
                     <a:lnB w="9525" cap="flat" cmpd="sng" algn="ctr">
                       <a:solidFill>
-                        <a:srgbClr val="E5E7EB"/>
+                        <a:srgbClr val="D9D2C5"/>
                       </a:solidFill>
                       <a:prstDash val="solid"/>
                       <a:round/>
@@ -8602,11 +8602,11 @@
             <a:r>
               <a:rPr lang="en-US" sz="1050" i="1" dirty="0">
                 <a:solidFill>
-                  <a:srgbClr val="6B7280"/>
-                </a:solidFill>
-                <a:latin typeface="Calibri" pitchFamily="34" charset="0"/>
-                <a:ea typeface="Calibri" pitchFamily="34" charset="-122"/>
-                <a:cs typeface="Calibri" pitchFamily="34" charset="-120"/>
+                  <a:srgbClr val="5C5C58"/>
+                </a:solidFill>
+                <a:latin typeface="Inter" pitchFamily="34" charset="0"/>
+                <a:ea typeface="Inter" pitchFamily="34" charset="-122"/>
+                <a:cs typeface="Inter" pitchFamily="34" charset="-120"/>
               </a:rPr>
               <a:t>Beispielpositionen · Preise netto zzgl. MwSt. · Gültig 30 Tage</a:t>
             </a:r>
@@ -8644,11 +8644,11 @@
             <a:lvl1pPr>
               <a:defRPr sz="900">
                 <a:solidFill>
-                  <a:srgbClr val="6B7280"/>
-                </a:solidFill>
-                <a:latin typeface="Calibri"/>
-                <a:ea typeface="Calibri"/>
-                <a:cs typeface="Calibri"/>
+                  <a:srgbClr val="5C5C58"/>
+                </a:solidFill>
+                <a:latin typeface="Inter"/>
+                <a:ea typeface="Inter"/>
+                <a:cs typeface="Inter"/>
               </a:defRPr>
             </a:lvl1pPr>
           </a:lstStyle>
@@ -8698,7 +8698,7 @@
         <p:spPr>
           <a:xfrm>
             <a:off x="457200" y="320040"/>
-            <a:ext cx="6217920" cy="685800"/>
+            <a:ext cx="6858000" cy="685800"/>
           </a:xfrm>
           <a:prstGeom prst="rect">
             <a:avLst/>
@@ -8716,11 +8716,11 @@
             <a:r>
               <a:rPr lang="en-US" sz="2800" b="1" dirty="0">
                 <a:solidFill>
-                  <a:srgbClr val="111827"/>
-                </a:solidFill>
-                <a:latin typeface="Calibri" pitchFamily="34" charset="0"/>
-                <a:ea typeface="Calibri" pitchFamily="34" charset="-122"/>
-                <a:cs typeface="Calibri" pitchFamily="34" charset="-120"/>
+                  <a:srgbClr val="0F0F0F"/>
+                </a:solidFill>
+                <a:latin typeface="Inter" pitchFamily="34" charset="0"/>
+                <a:ea typeface="Inter" pitchFamily="34" charset="-122"/>
+                <a:cs typeface="Inter" pitchFamily="34" charset="-120"/>
               </a:rPr>
               <a:t>Auftragsvolumen nach Produktgruppe</a:t>
             </a:r>
@@ -8761,11 +8761,11 @@
             </a:avLst>
           </a:prstGeom>
           <a:solidFill>
-            <a:srgbClr val="F3F4F6"/>
+            <a:srgbClr val="E8DFD0"/>
           </a:solidFill>
           <a:ln w="12700">
             <a:solidFill>
-              <a:srgbClr val="F3F4F6"/>
+              <a:srgbClr val="E8DFD0"/>
             </a:solidFill>
             <a:prstDash val="solid"/>
           </a:ln>
@@ -8798,11 +8798,11 @@
             <a:r>
               <a:rPr lang="en-US" sz="1100" i="1" dirty="0">
                 <a:solidFill>
-                  <a:srgbClr val="6B7280"/>
-                </a:solidFill>
-                <a:latin typeface="Calibri" pitchFamily="34" charset="0"/>
-                <a:ea typeface="Calibri" pitchFamily="34" charset="-122"/>
-                <a:cs typeface="Calibri" pitchFamily="34" charset="-120"/>
+                  <a:srgbClr val="5C5C58"/>
+                </a:solidFill>
+                <a:latin typeface="Inter" pitchFamily="34" charset="0"/>
+                <a:ea typeface="Inter" pitchFamily="34" charset="-122"/>
+                <a:cs typeface="Inter" pitchFamily="34" charset="-120"/>
               </a:rPr>
               <a:t>Beispieldaten</a:t>
             </a:r>
@@ -8837,11 +8837,11 @@
             <a:r>
               <a:rPr lang="en-US" sz="1600" b="1" dirty="0">
                 <a:solidFill>
-                  <a:srgbClr val="111827"/>
-                </a:solidFill>
-                <a:latin typeface="Calibri" pitchFamily="34" charset="0"/>
-                <a:ea typeface="Calibri" pitchFamily="34" charset="-122"/>
-                <a:cs typeface="Calibri" pitchFamily="34" charset="-120"/>
+                  <a:srgbClr val="0F0F0F"/>
+                </a:solidFill>
+                <a:latin typeface="Inter" pitchFamily="34" charset="0"/>
+                <a:ea typeface="Inter" pitchFamily="34" charset="-122"/>
+                <a:cs typeface="Inter" pitchFamily="34" charset="-120"/>
               </a:rPr>
               <a:t>T-Shirts machen den größten Anteil aus</a:t>
             </a:r>
@@ -8876,11 +8876,11 @@
             <a:r>
               <a:rPr lang="en-US" sz="1200" dirty="0">
                 <a:solidFill>
-                  <a:srgbClr val="6B7280"/>
-                </a:solidFill>
-                <a:latin typeface="Calibri" pitchFamily="34" charset="0"/>
-                <a:ea typeface="Calibri" pitchFamily="34" charset="-122"/>
-                <a:cs typeface="Calibri" pitchFamily="34" charset="-120"/>
+                  <a:srgbClr val="5C5C58"/>
+                </a:solidFill>
+                <a:latin typeface="Inter" pitchFamily="34" charset="0"/>
+                <a:ea typeface="Inter" pitchFamily="34" charset="-122"/>
+                <a:cs typeface="Inter" pitchFamily="34" charset="-120"/>
               </a:rPr>
               <a:t>Das Diagramm ist ein natives PowerPoint-Diagramm: Werte per Rechtsklick → „Daten bearbeiten“ ändern.</a:t>
             </a:r>
@@ -8918,11 +8918,11 @@
             <a:lvl1pPr>
               <a:defRPr sz="900">
                 <a:solidFill>
-                  <a:srgbClr val="6B7280"/>
-                </a:solidFill>
-                <a:latin typeface="Calibri"/>
-                <a:ea typeface="Calibri"/>
-                <a:cs typeface="Calibri"/>
+                  <a:srgbClr val="5C5C58"/>
+                </a:solidFill>
+                <a:latin typeface="Inter"/>
+                <a:ea typeface="Inter"/>
+                <a:cs typeface="Inter"/>
               </a:defRPr>
             </a:lvl1pPr>
           </a:lstStyle>
@@ -8972,7 +8972,7 @@
         <p:spPr>
           <a:xfrm>
             <a:off x="457200" y="320040"/>
-            <a:ext cx="6217920" cy="685800"/>
+            <a:ext cx="6858000" cy="685800"/>
           </a:xfrm>
           <a:prstGeom prst="rect">
             <a:avLst/>
@@ -8990,11 +8990,11 @@
             <a:r>
               <a:rPr lang="en-US" sz="2800" b="1" dirty="0">
                 <a:solidFill>
-                  <a:srgbClr val="111827"/>
-                </a:solidFill>
-                <a:latin typeface="Calibri" pitchFamily="34" charset="0"/>
-                <a:ea typeface="Calibri" pitchFamily="34" charset="-122"/>
-                <a:cs typeface="Calibri" pitchFamily="34" charset="-120"/>
+                  <a:srgbClr val="0F0F0F"/>
+                </a:solidFill>
+                <a:latin typeface="Inter" pitchFamily="34" charset="0"/>
+                <a:ea typeface="Inter" pitchFamily="34" charset="-122"/>
+                <a:cs typeface="Inter" pitchFamily="34" charset="-120"/>
               </a:rPr>
               <a:t>Folientitel</a:t>
             </a:r>
@@ -9033,11 +9033,11 @@
             <a:r>
               <a:rPr lang="en-US" sz="1600" dirty="0">
                 <a:solidFill>
-                  <a:srgbClr val="111827"/>
-                </a:solidFill>
-                <a:latin typeface="Calibri" pitchFamily="34" charset="0"/>
-                <a:ea typeface="Calibri" pitchFamily="34" charset="-122"/>
-                <a:cs typeface="Calibri" pitchFamily="34" charset="-120"/>
+                  <a:srgbClr val="0F0F0F"/>
+                </a:solidFill>
+                <a:latin typeface="Inter" pitchFamily="34" charset="0"/>
+                <a:ea typeface="Inter" pitchFamily="34" charset="-122"/>
+                <a:cs typeface="Inter" pitchFamily="34" charset="-120"/>
               </a:rPr>
               <a:t>Erste Aussage der Folie</a:t>
             </a:r>
@@ -9054,11 +9054,11 @@
             <a:r>
               <a:rPr lang="en-US" sz="1600" dirty="0">
                 <a:solidFill>
-                  <a:srgbClr val="111827"/>
-                </a:solidFill>
-                <a:latin typeface="Calibri" pitchFamily="34" charset="0"/>
-                <a:ea typeface="Calibri" pitchFamily="34" charset="-122"/>
-                <a:cs typeface="Calibri" pitchFamily="34" charset="-120"/>
+                  <a:srgbClr val="0F0F0F"/>
+                </a:solidFill>
+                <a:latin typeface="Inter" pitchFamily="34" charset="0"/>
+                <a:ea typeface="Inter" pitchFamily="34" charset="-122"/>
+                <a:cs typeface="Inter" pitchFamily="34" charset="-120"/>
               </a:rPr>
               <a:t>Zweite Aussage mit einer kurzen Erläuterung</a:t>
             </a:r>
@@ -9075,11 +9075,11 @@
             <a:r>
               <a:rPr lang="en-US" sz="1600" dirty="0">
                 <a:solidFill>
-                  <a:srgbClr val="111827"/>
-                </a:solidFill>
-                <a:latin typeface="Calibri" pitchFamily="34" charset="0"/>
-                <a:ea typeface="Calibri" pitchFamily="34" charset="-122"/>
-                <a:cs typeface="Calibri" pitchFamily="34" charset="-120"/>
+                  <a:srgbClr val="0F0F0F"/>
+                </a:solidFill>
+                <a:latin typeface="Inter" pitchFamily="34" charset="0"/>
+                <a:ea typeface="Inter" pitchFamily="34" charset="-122"/>
+                <a:cs typeface="Inter" pitchFamily="34" charset="-120"/>
               </a:rPr>
               <a:t>Dritte Aussage</a:t>
             </a:r>
@@ -9096,11 +9096,11 @@
             <a:r>
               <a:rPr lang="en-US" sz="1600" dirty="0">
                 <a:solidFill>
-                  <a:srgbClr val="111827"/>
-                </a:solidFill>
-                <a:latin typeface="Calibri" pitchFamily="34" charset="0"/>
-                <a:ea typeface="Calibri" pitchFamily="34" charset="-122"/>
-                <a:cs typeface="Calibri" pitchFamily="34" charset="-120"/>
+                  <a:srgbClr val="0F0F0F"/>
+                </a:solidFill>
+                <a:latin typeface="Inter" pitchFamily="34" charset="0"/>
+                <a:ea typeface="Inter" pitchFamily="34" charset="-122"/>
+                <a:cs typeface="Inter" pitchFamily="34" charset="-120"/>
               </a:rPr>
               <a:t>Unterpunkt zur dritten Aussage</a:t>
             </a:r>
@@ -9117,11 +9117,11 @@
             <a:r>
               <a:rPr lang="en-US" sz="1600" dirty="0">
                 <a:solidFill>
-                  <a:srgbClr val="111827"/>
-                </a:solidFill>
-                <a:latin typeface="Calibri" pitchFamily="34" charset="0"/>
-                <a:ea typeface="Calibri" pitchFamily="34" charset="-122"/>
-                <a:cs typeface="Calibri" pitchFamily="34" charset="-120"/>
+                  <a:srgbClr val="0F0F0F"/>
+                </a:solidFill>
+                <a:latin typeface="Inter" pitchFamily="34" charset="0"/>
+                <a:ea typeface="Inter" pitchFamily="34" charset="-122"/>
+                <a:cs typeface="Inter" pitchFamily="34" charset="-120"/>
               </a:rPr>
               <a:t>Weiterer Unterpunkt</a:t>
             </a:r>
@@ -9146,11 +9146,11 @@
             </a:avLst>
           </a:prstGeom>
           <a:solidFill>
-            <a:srgbClr val="F3F4F6"/>
+            <a:srgbClr val="E8DFD0"/>
           </a:solidFill>
           <a:ln w="12700">
             <a:solidFill>
-              <a:srgbClr val="F3F4F6"/>
+              <a:srgbClr val="E8DFD0"/>
             </a:solidFill>
             <a:prstDash val="solid"/>
           </a:ln>
@@ -9232,11 +9232,11 @@
             <a:r>
               <a:rPr lang="en-US" sz="1200" dirty="0">
                 <a:solidFill>
-                  <a:srgbClr val="6B7280"/>
-                </a:solidFill>
-                <a:latin typeface="Calibri" pitchFamily="34" charset="0"/>
-                <a:ea typeface="Calibri" pitchFamily="34" charset="-122"/>
-                <a:cs typeface="Calibri" pitchFamily="34" charset="-120"/>
+                  <a:srgbClr val="5C5C58"/>
+                </a:solidFill>
+                <a:latin typeface="Inter" pitchFamily="34" charset="0"/>
+                <a:ea typeface="Inter" pitchFamily="34" charset="-122"/>
+                <a:cs typeface="Inter" pitchFamily="34" charset="-120"/>
               </a:rPr>
               <a:t>Platz für Bild, Grafik oder Zitat</a:t>
             </a:r>
@@ -9274,11 +9274,11 @@
             <a:lvl1pPr>
               <a:defRPr sz="900">
                 <a:solidFill>
-                  <a:srgbClr val="6B7280"/>
-                </a:solidFill>
-                <a:latin typeface="Calibri"/>
-                <a:ea typeface="Calibri"/>
-                <a:cs typeface="Calibri"/>
+                  <a:srgbClr val="5C5C58"/>
+                </a:solidFill>
+                <a:latin typeface="Inter"/>
+                <a:ea typeface="Inter"/>
+                <a:cs typeface="Inter"/>
               </a:defRPr>
             </a:lvl1pPr>
           </a:lstStyle>

</xml_diff>